<commit_message>
PIN Cleanup and Presentation Work: - Worked on presentation to add more valid and formatted information. - Made it so that PINs now have to be 4 digits long.    - A future update needs to convert these into strings so that they can have a 0 in the leading spot, right now they cannot without throwing errors. - Updated test cases to reflect the new logic and fix one of the cases that broke.
</commit_message>
<xml_diff>
--- a/documents/Bank repl.pptx
+++ b/documents/Bank repl.pptx
@@ -4,11 +4,15 @@
   <p:sldMasterIdLst>
     <p:sldMasterId id="2147483660" r:id="rId1"/>
   </p:sldMasterIdLst>
+  <p:notesMasterIdLst>
+    <p:notesMasterId r:id="rId7"/>
+  </p:notesMasterIdLst>
   <p:sldIdLst>
     <p:sldId id="256" r:id="rId2"/>
     <p:sldId id="258" r:id="rId3"/>
     <p:sldId id="259" r:id="rId4"/>
     <p:sldId id="260" r:id="rId5"/>
+    <p:sldId id="261" r:id="rId6"/>
   </p:sldIdLst>
   <p:sldSz cx="12192000" cy="6858000"/>
   <p:notesSz cx="6858000" cy="9144000"/>
@@ -191,6 +195,439 @@
 </pc:chgInfo>
 </file>
 
+<file path=ppt/notesMasters/notesMaster1.xml><?xml version="1.0" encoding="utf-8"?>
+<p:notesMaster xmlns:a="http://schemas.openxmlformats.org/drawingml/2006/main" xmlns:r="http://schemas.openxmlformats.org/officeDocument/2006/relationships" xmlns:p="http://schemas.openxmlformats.org/presentationml/2006/main">
+  <p:cSld>
+    <p:bg>
+      <p:bgRef idx="1001">
+        <a:schemeClr val="bg1"/>
+      </p:bgRef>
+    </p:bg>
+    <p:spTree>
+      <p:nvGrpSpPr>
+        <p:cNvPr id="1" name=""/>
+        <p:cNvGrpSpPr/>
+        <p:nvPr/>
+      </p:nvGrpSpPr>
+      <p:grpSpPr>
+        <a:xfrm>
+          <a:off x="0" y="0"/>
+          <a:ext cx="0" cy="0"/>
+          <a:chOff x="0" y="0"/>
+          <a:chExt cx="0" cy="0"/>
+        </a:xfrm>
+      </p:grpSpPr>
+      <p:sp>
+        <p:nvSpPr>
+          <p:cNvPr id="2" name="Header Placeholder 1"/>
+          <p:cNvSpPr>
+            <a:spLocks noGrp="1"/>
+          </p:cNvSpPr>
+          <p:nvPr>
+            <p:ph type="hdr" sz="quarter"/>
+          </p:nvPr>
+        </p:nvSpPr>
+        <p:spPr>
+          <a:xfrm>
+            <a:off x="0" y="0"/>
+            <a:ext cx="2971800" cy="458788"/>
+          </a:xfrm>
+          <a:prstGeom prst="rect">
+            <a:avLst/>
+          </a:prstGeom>
+        </p:spPr>
+        <p:txBody>
+          <a:bodyPr vert="horz" lIns="91440" tIns="45720" rIns="91440" bIns="45720" rtlCol="0"/>
+          <a:lstStyle>
+            <a:lvl1pPr algn="l">
+              <a:defRPr sz="1200"/>
+            </a:lvl1pPr>
+          </a:lstStyle>
+          <a:p>
+            <a:endParaRPr lang="en-US"/>
+          </a:p>
+        </p:txBody>
+      </p:sp>
+      <p:sp>
+        <p:nvSpPr>
+          <p:cNvPr id="3" name="Date Placeholder 2"/>
+          <p:cNvSpPr>
+            <a:spLocks noGrp="1"/>
+          </p:cNvSpPr>
+          <p:nvPr>
+            <p:ph type="dt" idx="1"/>
+          </p:nvPr>
+        </p:nvSpPr>
+        <p:spPr>
+          <a:xfrm>
+            <a:off x="3884613" y="0"/>
+            <a:ext cx="2971800" cy="458788"/>
+          </a:xfrm>
+          <a:prstGeom prst="rect">
+            <a:avLst/>
+          </a:prstGeom>
+        </p:spPr>
+        <p:txBody>
+          <a:bodyPr vert="horz" lIns="91440" tIns="45720" rIns="91440" bIns="45720" rtlCol="0"/>
+          <a:lstStyle>
+            <a:lvl1pPr algn="r">
+              <a:defRPr sz="1200"/>
+            </a:lvl1pPr>
+          </a:lstStyle>
+          <a:p>
+            <a:fld id="{7E6B9F9D-34EC-4863-8EB5-F867A2E8E499}" type="datetimeFigureOut">
+              <a:rPr lang="en-US" smtClean="0"/>
+              <a:t>9/24/2026</a:t>
+            </a:fld>
+            <a:endParaRPr lang="en-US"/>
+          </a:p>
+        </p:txBody>
+      </p:sp>
+      <p:sp>
+        <p:nvSpPr>
+          <p:cNvPr id="4" name="Slide Image Placeholder 3"/>
+          <p:cNvSpPr>
+            <a:spLocks noGrp="1" noRot="1" noChangeAspect="1"/>
+          </p:cNvSpPr>
+          <p:nvPr>
+            <p:ph type="sldImg" idx="2"/>
+          </p:nvPr>
+        </p:nvSpPr>
+        <p:spPr>
+          <a:xfrm>
+            <a:off x="685800" y="1143000"/>
+            <a:ext cx="5486400" cy="3086100"/>
+          </a:xfrm>
+          <a:prstGeom prst="rect">
+            <a:avLst/>
+          </a:prstGeom>
+          <a:noFill/>
+          <a:ln w="12700">
+            <a:solidFill>
+              <a:prstClr val="black"/>
+            </a:solidFill>
+          </a:ln>
+        </p:spPr>
+        <p:txBody>
+          <a:bodyPr vert="horz" lIns="91440" tIns="45720" rIns="91440" bIns="45720" rtlCol="0" anchor="ctr"/>
+          <a:lstStyle/>
+          <a:p>
+            <a:endParaRPr lang="en-US"/>
+          </a:p>
+        </p:txBody>
+      </p:sp>
+      <p:sp>
+        <p:nvSpPr>
+          <p:cNvPr id="5" name="Notes Placeholder 4"/>
+          <p:cNvSpPr>
+            <a:spLocks noGrp="1"/>
+          </p:cNvSpPr>
+          <p:nvPr>
+            <p:ph type="body" sz="quarter" idx="3"/>
+          </p:nvPr>
+        </p:nvSpPr>
+        <p:spPr>
+          <a:xfrm>
+            <a:off x="685800" y="4400550"/>
+            <a:ext cx="5486400" cy="3600450"/>
+          </a:xfrm>
+          <a:prstGeom prst="rect">
+            <a:avLst/>
+          </a:prstGeom>
+        </p:spPr>
+        <p:txBody>
+          <a:bodyPr vert="horz" lIns="91440" tIns="45720" rIns="91440" bIns="45720" rtlCol="0"/>
+          <a:lstStyle/>
+          <a:p>
+            <a:pPr lvl="0"/>
+            <a:r>
+              <a:rPr lang="en-US"/>
+              <a:t>Click to edit Master text styles</a:t>
+            </a:r>
+          </a:p>
+          <a:p>
+            <a:pPr lvl="1"/>
+            <a:r>
+              <a:rPr lang="en-US"/>
+              <a:t>Second level</a:t>
+            </a:r>
+          </a:p>
+          <a:p>
+            <a:pPr lvl="2"/>
+            <a:r>
+              <a:rPr lang="en-US"/>
+              <a:t>Third level</a:t>
+            </a:r>
+          </a:p>
+          <a:p>
+            <a:pPr lvl="3"/>
+            <a:r>
+              <a:rPr lang="en-US"/>
+              <a:t>Fourth level</a:t>
+            </a:r>
+          </a:p>
+          <a:p>
+            <a:pPr lvl="4"/>
+            <a:r>
+              <a:rPr lang="en-US"/>
+              <a:t>Fifth level</a:t>
+            </a:r>
+          </a:p>
+        </p:txBody>
+      </p:sp>
+      <p:sp>
+        <p:nvSpPr>
+          <p:cNvPr id="6" name="Footer Placeholder 5"/>
+          <p:cNvSpPr>
+            <a:spLocks noGrp="1"/>
+          </p:cNvSpPr>
+          <p:nvPr>
+            <p:ph type="ftr" sz="quarter" idx="4"/>
+          </p:nvPr>
+        </p:nvSpPr>
+        <p:spPr>
+          <a:xfrm>
+            <a:off x="0" y="8685213"/>
+            <a:ext cx="2971800" cy="458787"/>
+          </a:xfrm>
+          <a:prstGeom prst="rect">
+            <a:avLst/>
+          </a:prstGeom>
+        </p:spPr>
+        <p:txBody>
+          <a:bodyPr vert="horz" lIns="91440" tIns="45720" rIns="91440" bIns="45720" rtlCol="0" anchor="b"/>
+          <a:lstStyle>
+            <a:lvl1pPr algn="l">
+              <a:defRPr sz="1200"/>
+            </a:lvl1pPr>
+          </a:lstStyle>
+          <a:p>
+            <a:endParaRPr lang="en-US"/>
+          </a:p>
+        </p:txBody>
+      </p:sp>
+      <p:sp>
+        <p:nvSpPr>
+          <p:cNvPr id="7" name="Slide Number Placeholder 6"/>
+          <p:cNvSpPr>
+            <a:spLocks noGrp="1"/>
+          </p:cNvSpPr>
+          <p:nvPr>
+            <p:ph type="sldNum" sz="quarter" idx="5"/>
+          </p:nvPr>
+        </p:nvSpPr>
+        <p:spPr>
+          <a:xfrm>
+            <a:off x="3884613" y="8685213"/>
+            <a:ext cx="2971800" cy="458787"/>
+          </a:xfrm>
+          <a:prstGeom prst="rect">
+            <a:avLst/>
+          </a:prstGeom>
+        </p:spPr>
+        <p:txBody>
+          <a:bodyPr vert="horz" lIns="91440" tIns="45720" rIns="91440" bIns="45720" rtlCol="0" anchor="b"/>
+          <a:lstStyle>
+            <a:lvl1pPr algn="r">
+              <a:defRPr sz="1200"/>
+            </a:lvl1pPr>
+          </a:lstStyle>
+          <a:p>
+            <a:fld id="{78D4AC4A-0267-4A53-9FBB-82E7EAC6F562}" type="slidenum">
+              <a:rPr lang="en-US" smtClean="0"/>
+              <a:t>‹#›</a:t>
+            </a:fld>
+            <a:endParaRPr lang="en-US"/>
+          </a:p>
+        </p:txBody>
+      </p:sp>
+    </p:spTree>
+    <p:extLst>
+      <p:ext uri="{BB962C8B-B14F-4D97-AF65-F5344CB8AC3E}">
+        <p14:creationId xmlns:p14="http://schemas.microsoft.com/office/powerpoint/2010/main" val="2311263006"/>
+      </p:ext>
+    </p:extLst>
+  </p:cSld>
+  <p:clrMap bg1="lt1" tx1="dk1" bg2="lt2" tx2="dk2" accent1="accent1" accent2="accent2" accent3="accent3" accent4="accent4" accent5="accent5" accent6="accent6" hlink="hlink" folHlink="folHlink"/>
+  <p:notesStyle>
+    <a:lvl1pPr marL="0" algn="l" defTabSz="914400" rtl="0" eaLnBrk="1" latinLnBrk="0" hangingPunct="1">
+      <a:defRPr sz="1200" kern="1200">
+        <a:solidFill>
+          <a:schemeClr val="tx1"/>
+        </a:solidFill>
+        <a:latin typeface="+mn-lt"/>
+        <a:ea typeface="+mn-ea"/>
+        <a:cs typeface="+mn-cs"/>
+      </a:defRPr>
+    </a:lvl1pPr>
+    <a:lvl2pPr marL="457200" algn="l" defTabSz="914400" rtl="0" eaLnBrk="1" latinLnBrk="0" hangingPunct="1">
+      <a:defRPr sz="1200" kern="1200">
+        <a:solidFill>
+          <a:schemeClr val="tx1"/>
+        </a:solidFill>
+        <a:latin typeface="+mn-lt"/>
+        <a:ea typeface="+mn-ea"/>
+        <a:cs typeface="+mn-cs"/>
+      </a:defRPr>
+    </a:lvl2pPr>
+    <a:lvl3pPr marL="914400" algn="l" defTabSz="914400" rtl="0" eaLnBrk="1" latinLnBrk="0" hangingPunct="1">
+      <a:defRPr sz="1200" kern="1200">
+        <a:solidFill>
+          <a:schemeClr val="tx1"/>
+        </a:solidFill>
+        <a:latin typeface="+mn-lt"/>
+        <a:ea typeface="+mn-ea"/>
+        <a:cs typeface="+mn-cs"/>
+      </a:defRPr>
+    </a:lvl3pPr>
+    <a:lvl4pPr marL="1371600" algn="l" defTabSz="914400" rtl="0" eaLnBrk="1" latinLnBrk="0" hangingPunct="1">
+      <a:defRPr sz="1200" kern="1200">
+        <a:solidFill>
+          <a:schemeClr val="tx1"/>
+        </a:solidFill>
+        <a:latin typeface="+mn-lt"/>
+        <a:ea typeface="+mn-ea"/>
+        <a:cs typeface="+mn-cs"/>
+      </a:defRPr>
+    </a:lvl4pPr>
+    <a:lvl5pPr marL="1828800" algn="l" defTabSz="914400" rtl="0" eaLnBrk="1" latinLnBrk="0" hangingPunct="1">
+      <a:defRPr sz="1200" kern="1200">
+        <a:solidFill>
+          <a:schemeClr val="tx1"/>
+        </a:solidFill>
+        <a:latin typeface="+mn-lt"/>
+        <a:ea typeface="+mn-ea"/>
+        <a:cs typeface="+mn-cs"/>
+      </a:defRPr>
+    </a:lvl5pPr>
+    <a:lvl6pPr marL="2286000" algn="l" defTabSz="914400" rtl="0" eaLnBrk="1" latinLnBrk="0" hangingPunct="1">
+      <a:defRPr sz="1200" kern="1200">
+        <a:solidFill>
+          <a:schemeClr val="tx1"/>
+        </a:solidFill>
+        <a:latin typeface="+mn-lt"/>
+        <a:ea typeface="+mn-ea"/>
+        <a:cs typeface="+mn-cs"/>
+      </a:defRPr>
+    </a:lvl6pPr>
+    <a:lvl7pPr marL="2743200" algn="l" defTabSz="914400" rtl="0" eaLnBrk="1" latinLnBrk="0" hangingPunct="1">
+      <a:defRPr sz="1200" kern="1200">
+        <a:solidFill>
+          <a:schemeClr val="tx1"/>
+        </a:solidFill>
+        <a:latin typeface="+mn-lt"/>
+        <a:ea typeface="+mn-ea"/>
+        <a:cs typeface="+mn-cs"/>
+      </a:defRPr>
+    </a:lvl7pPr>
+    <a:lvl8pPr marL="3200400" algn="l" defTabSz="914400" rtl="0" eaLnBrk="1" latinLnBrk="0" hangingPunct="1">
+      <a:defRPr sz="1200" kern="1200">
+        <a:solidFill>
+          <a:schemeClr val="tx1"/>
+        </a:solidFill>
+        <a:latin typeface="+mn-lt"/>
+        <a:ea typeface="+mn-ea"/>
+        <a:cs typeface="+mn-cs"/>
+      </a:defRPr>
+    </a:lvl8pPr>
+    <a:lvl9pPr marL="3657600" algn="l" defTabSz="914400" rtl="0" eaLnBrk="1" latinLnBrk="0" hangingPunct="1">
+      <a:defRPr sz="1200" kern="1200">
+        <a:solidFill>
+          <a:schemeClr val="tx1"/>
+        </a:solidFill>
+        <a:latin typeface="+mn-lt"/>
+        <a:ea typeface="+mn-ea"/>
+        <a:cs typeface="+mn-cs"/>
+      </a:defRPr>
+    </a:lvl9pPr>
+  </p:notesStyle>
+</p:notesMaster>
+</file>
+
+<file path=ppt/notesSlides/notesSlide1.xml><?xml version="1.0" encoding="utf-8"?>
+<p:notes xmlns:a="http://schemas.openxmlformats.org/drawingml/2006/main" xmlns:r="http://schemas.openxmlformats.org/officeDocument/2006/relationships" xmlns:p="http://schemas.openxmlformats.org/presentationml/2006/main">
+  <p:cSld>
+    <p:spTree>
+      <p:nvGrpSpPr>
+        <p:cNvPr id="1" name=""/>
+        <p:cNvGrpSpPr/>
+        <p:nvPr/>
+      </p:nvGrpSpPr>
+      <p:grpSpPr>
+        <a:xfrm>
+          <a:off x="0" y="0"/>
+          <a:ext cx="0" cy="0"/>
+          <a:chOff x="0" y="0"/>
+          <a:chExt cx="0" cy="0"/>
+        </a:xfrm>
+      </p:grpSpPr>
+      <p:sp>
+        <p:nvSpPr>
+          <p:cNvPr id="2" name="Slide Image Placeholder 1"/>
+          <p:cNvSpPr>
+            <a:spLocks noGrp="1" noRot="1" noChangeAspect="1"/>
+          </p:cNvSpPr>
+          <p:nvPr>
+            <p:ph type="sldImg"/>
+          </p:nvPr>
+        </p:nvSpPr>
+        <p:spPr/>
+      </p:sp>
+      <p:sp>
+        <p:nvSpPr>
+          <p:cNvPr id="3" name="Notes Placeholder 2"/>
+          <p:cNvSpPr>
+            <a:spLocks noGrp="1"/>
+          </p:cNvSpPr>
+          <p:nvPr>
+            <p:ph type="body" idx="1"/>
+          </p:nvPr>
+        </p:nvSpPr>
+        <p:spPr/>
+        <p:txBody>
+          <a:bodyPr/>
+          <a:lstStyle/>
+          <a:p>
+            <a:endParaRPr lang="en-US"/>
+          </a:p>
+        </p:txBody>
+      </p:sp>
+      <p:sp>
+        <p:nvSpPr>
+          <p:cNvPr id="4" name="Slide Number Placeholder 3"/>
+          <p:cNvSpPr>
+            <a:spLocks noGrp="1"/>
+          </p:cNvSpPr>
+          <p:nvPr>
+            <p:ph type="sldNum" sz="quarter" idx="5"/>
+          </p:nvPr>
+        </p:nvSpPr>
+        <p:spPr/>
+        <p:txBody>
+          <a:bodyPr/>
+          <a:lstStyle/>
+          <a:p>
+            <a:fld id="{78D4AC4A-0267-4A53-9FBB-82E7EAC6F562}" type="slidenum">
+              <a:rPr lang="en-US" smtClean="0"/>
+              <a:t>3</a:t>
+            </a:fld>
+            <a:endParaRPr lang="en-US"/>
+          </a:p>
+        </p:txBody>
+      </p:sp>
+    </p:spTree>
+    <p:extLst>
+      <p:ext uri="{BB962C8B-B14F-4D97-AF65-F5344CB8AC3E}">
+        <p14:creationId xmlns:p14="http://schemas.microsoft.com/office/powerpoint/2010/main" val="3996449193"/>
+      </p:ext>
+    </p:extLst>
+  </p:cSld>
+  <p:clrMapOvr>
+    <a:masterClrMapping/>
+  </p:clrMapOvr>
+</p:notes>
+</file>
+
 <file path=ppt/slideLayouts/slideLayout1.xml><?xml version="1.0" encoding="utf-8"?>
 <p:sldLayout xmlns:a="http://schemas.openxmlformats.org/drawingml/2006/main" xmlns:r="http://schemas.openxmlformats.org/officeDocument/2006/relationships" xmlns:p="http://schemas.openxmlformats.org/presentationml/2006/main" showMasterSp="0" preserve="1">
   <p:cSld name="Title">
@@ -372,7 +809,7 @@
           <a:p>
             <a:fld id="{DD20782C-0F45-447A-BF23-AC527316A4E0}" type="datetimeFigureOut">
               <a:rPr lang="en-US" smtClean="0"/>
-              <a:t>9/21/2026</a:t>
+              <a:t>9/24/2026</a:t>
             </a:fld>
             <a:endParaRPr lang="en-US"/>
           </a:p>
@@ -764,7 +1201,7 @@
           <a:p>
             <a:fld id="{DD20782C-0F45-447A-BF23-AC527316A4E0}" type="datetimeFigureOut">
               <a:rPr lang="en-US" smtClean="0"/>
-              <a:t>9/21/2026</a:t>
+              <a:t>9/24/2026</a:t>
             </a:fld>
             <a:endParaRPr lang="en-US"/>
           </a:p>
@@ -1115,7 +1552,7 @@
           <a:p>
             <a:fld id="{DD20782C-0F45-447A-BF23-AC527316A4E0}" type="datetimeFigureOut">
               <a:rPr lang="en-US" smtClean="0"/>
-              <a:t>9/21/2026</a:t>
+              <a:t>9/24/2026</a:t>
             </a:fld>
             <a:endParaRPr lang="en-US"/>
           </a:p>
@@ -1419,7 +1856,7 @@
           <a:p>
             <a:fld id="{DD20782C-0F45-447A-BF23-AC527316A4E0}" type="datetimeFigureOut">
               <a:rPr lang="en-US" smtClean="0"/>
-              <a:t>9/21/2026</a:t>
+              <a:t>9/24/2026</a:t>
             </a:fld>
             <a:endParaRPr lang="en-US"/>
           </a:p>
@@ -1774,7 +2211,7 @@
           <a:p>
             <a:fld id="{DD20782C-0F45-447A-BF23-AC527316A4E0}" type="datetimeFigureOut">
               <a:rPr lang="en-US" smtClean="0"/>
-              <a:t>9/21/2026</a:t>
+              <a:t>9/24/2026</a:t>
             </a:fld>
             <a:endParaRPr lang="en-US"/>
           </a:p>
@@ -2129,7 +2566,7 @@
           <a:p>
             <a:fld id="{DD20782C-0F45-447A-BF23-AC527316A4E0}" type="datetimeFigureOut">
               <a:rPr lang="en-US" smtClean="0"/>
-              <a:t>9/21/2026</a:t>
+              <a:t>9/24/2026</a:t>
             </a:fld>
             <a:endParaRPr lang="en-US"/>
           </a:p>
@@ -2580,7 +3017,7 @@
           <a:p>
             <a:fld id="{DD20782C-0F45-447A-BF23-AC527316A4E0}" type="datetimeFigureOut">
               <a:rPr lang="en-US" smtClean="0"/>
-              <a:t>9/21/2026</a:t>
+              <a:t>9/24/2026</a:t>
             </a:fld>
             <a:endParaRPr lang="en-US"/>
           </a:p>
@@ -2907,7 +3344,7 @@
           <a:p>
             <a:fld id="{DD20782C-0F45-447A-BF23-AC527316A4E0}" type="datetimeFigureOut">
               <a:rPr lang="en-US" smtClean="0"/>
-              <a:t>9/21/2026</a:t>
+              <a:t>9/24/2026</a:t>
             </a:fld>
             <a:endParaRPr lang="en-US"/>
           </a:p>
@@ -3327,7 +3764,7 @@
           <a:p>
             <a:fld id="{DD20782C-0F45-447A-BF23-AC527316A4E0}" type="datetimeFigureOut">
               <a:rPr lang="en-US" smtClean="0"/>
-              <a:t>9/21/2026</a:t>
+              <a:t>9/24/2026</a:t>
             </a:fld>
             <a:endParaRPr lang="en-US"/>
           </a:p>
@@ -3621,7 +4058,7 @@
           <a:p>
             <a:fld id="{DD20782C-0F45-447A-BF23-AC527316A4E0}" type="datetimeFigureOut">
               <a:rPr lang="en-US" smtClean="0"/>
-              <a:t>9/21/2026</a:t>
+              <a:t>9/24/2026</a:t>
             </a:fld>
             <a:endParaRPr lang="en-US"/>
           </a:p>
@@ -3894,7 +4331,7 @@
           <a:p>
             <a:fld id="{DD20782C-0F45-447A-BF23-AC527316A4E0}" type="datetimeFigureOut">
               <a:rPr lang="en-US" smtClean="0"/>
-              <a:t>9/21/2026</a:t>
+              <a:t>9/24/2026</a:t>
             </a:fld>
             <a:endParaRPr lang="en-US"/>
           </a:p>
@@ -4174,7 +4611,7 @@
           <a:p>
             <a:fld id="{DD20782C-0F45-447A-BF23-AC527316A4E0}" type="datetimeFigureOut">
               <a:rPr lang="en-US" smtClean="0"/>
-              <a:t>9/21/2026</a:t>
+              <a:t>9/24/2026</a:t>
             </a:fld>
             <a:endParaRPr lang="en-US"/>
           </a:p>
@@ -4474,7 +4911,7 @@
           <a:p>
             <a:fld id="{DD20782C-0F45-447A-BF23-AC527316A4E0}" type="datetimeFigureOut">
               <a:rPr lang="en-US" smtClean="0"/>
-              <a:t>9/21/2026</a:t>
+              <a:t>9/24/2026</a:t>
             </a:fld>
             <a:endParaRPr lang="en-US"/>
           </a:p>
@@ -4722,7 +5159,7 @@
           <a:p>
             <a:fld id="{DD20782C-0F45-447A-BF23-AC527316A4E0}" type="datetimeFigureOut">
               <a:rPr lang="en-US" smtClean="0"/>
-              <a:t>9/21/2026</a:t>
+              <a:t>9/24/2026</a:t>
             </a:fld>
             <a:endParaRPr lang="en-US"/>
           </a:p>
@@ -5125,7 +5562,7 @@
           <a:p>
             <a:fld id="{DD20782C-0F45-447A-BF23-AC527316A4E0}" type="datetimeFigureOut">
               <a:rPr lang="en-US" smtClean="0"/>
-              <a:t>9/21/2026</a:t>
+              <a:t>9/24/2026</a:t>
             </a:fld>
             <a:endParaRPr lang="en-US"/>
           </a:p>
@@ -5664,7 +6101,7 @@
           <a:p>
             <a:fld id="{DD20782C-0F45-447A-BF23-AC527316A4E0}" type="datetimeFigureOut">
               <a:rPr lang="en-US" smtClean="0"/>
-              <a:t>9/21/2026</a:t>
+              <a:t>9/24/2026</a:t>
             </a:fld>
             <a:endParaRPr lang="en-US"/>
           </a:p>
@@ -5863,7 +6300,7 @@
           <a:p>
             <a:fld id="{DD20782C-0F45-447A-BF23-AC527316A4E0}" type="datetimeFigureOut">
               <a:rPr lang="en-US" smtClean="0"/>
-              <a:t>9/21/2026</a:t>
+              <a:t>9/24/2026</a:t>
             </a:fld>
             <a:endParaRPr lang="en-US"/>
           </a:p>
@@ -6022,7 +6459,7 @@
           <a:p>
             <a:fld id="{DD20782C-0F45-447A-BF23-AC527316A4E0}" type="datetimeFigureOut">
               <a:rPr lang="en-US" smtClean="0"/>
-              <a:t>9/21/2026</a:t>
+              <a:t>9/24/2026</a:t>
             </a:fld>
             <a:endParaRPr lang="en-US"/>
           </a:p>
@@ -6319,7 +6756,7 @@
           <a:p>
             <a:fld id="{DD20782C-0F45-447A-BF23-AC527316A4E0}" type="datetimeFigureOut">
               <a:rPr lang="en-US" smtClean="0"/>
-              <a:t>9/21/2026</a:t>
+              <a:t>9/24/2026</a:t>
             </a:fld>
             <a:endParaRPr lang="en-US"/>
           </a:p>
@@ -6672,7 +7109,7 @@
           <a:p>
             <a:fld id="{DD20782C-0F45-447A-BF23-AC527316A4E0}" type="datetimeFigureOut">
               <a:rPr lang="en-US" smtClean="0"/>
-              <a:t>9/21/2026</a:t>
+              <a:t>9/24/2026</a:t>
             </a:fld>
             <a:endParaRPr lang="en-US"/>
           </a:p>
@@ -6921,7 +7358,7 @@
           <a:p>
             <a:fld id="{DD20782C-0F45-447A-BF23-AC527316A4E0}" type="datetimeFigureOut">
               <a:rPr lang="en-US" smtClean="0"/>
-              <a:t>9/21/2026</a:t>
+              <a:t>9/24/2026</a:t>
             </a:fld>
             <a:endParaRPr lang="en-US"/>
           </a:p>
@@ -7238,7 +7675,7 @@
           <a:p>
             <a:fld id="{DD20782C-0F45-447A-BF23-AC527316A4E0}" type="datetimeFigureOut">
               <a:rPr lang="en-US" smtClean="0"/>
-              <a:t>9/21/2026</a:t>
+              <a:t>9/24/2026</a:t>
             </a:fld>
             <a:endParaRPr lang="en-US"/>
           </a:p>
@@ -7558,7 +7995,7 @@
           <a:p>
             <a:fld id="{DD20782C-0F45-447A-BF23-AC527316A4E0}" type="datetimeFigureOut">
               <a:rPr lang="en-US" smtClean="0"/>
-              <a:t>9/21/2026</a:t>
+              <a:t>9/24/2026</a:t>
             </a:fld>
             <a:endParaRPr lang="en-US"/>
           </a:p>
@@ -7759,7 +8196,7 @@
           <a:p>
             <a:fld id="{DD20782C-0F45-447A-BF23-AC527316A4E0}" type="datetimeFigureOut">
               <a:rPr lang="en-US" smtClean="0"/>
-              <a:t>9/21/2026</a:t>
+              <a:t>9/24/2026</a:t>
             </a:fld>
             <a:endParaRPr lang="en-US"/>
           </a:p>
@@ -8071,7 +8508,7 @@
           <a:p>
             <a:fld id="{DD20782C-0F45-447A-BF23-AC527316A4E0}" type="datetimeFigureOut">
               <a:rPr lang="en-US" smtClean="0"/>
-              <a:t>9/21/2026</a:t>
+              <a:t>9/24/2026</a:t>
             </a:fld>
             <a:endParaRPr lang="en-US"/>
           </a:p>
@@ -8377,7 +8814,7 @@
           <a:p>
             <a:fld id="{DD20782C-0F45-447A-BF23-AC527316A4E0}" type="datetimeFigureOut">
               <a:rPr lang="en-US" smtClean="0"/>
-              <a:t>9/21/2026</a:t>
+              <a:t>9/24/2026</a:t>
             </a:fld>
             <a:endParaRPr lang="en-US"/>
           </a:p>
@@ -8723,7 +9160,7 @@
           <a:p>
             <a:fld id="{DD20782C-0F45-447A-BF23-AC527316A4E0}" type="datetimeFigureOut">
               <a:rPr lang="en-US" smtClean="0"/>
-              <a:t>9/21/2026</a:t>
+              <a:t>9/24/2026</a:t>
             </a:fld>
             <a:endParaRPr lang="en-US"/>
           </a:p>
@@ -9018,7 +9455,7 @@
           <a:p>
             <a:fld id="{DD20782C-0F45-447A-BF23-AC527316A4E0}" type="datetimeFigureOut">
               <a:rPr lang="en-US" smtClean="0"/>
-              <a:t>9/21/2026</a:t>
+              <a:t>9/24/2026</a:t>
             </a:fld>
             <a:endParaRPr lang="en-US"/>
           </a:p>
@@ -9321,7 +9758,7 @@
           <a:p>
             <a:fld id="{DD20782C-0F45-447A-BF23-AC527316A4E0}" type="datetimeFigureOut">
               <a:rPr lang="en-US" smtClean="0"/>
-              <a:t>9/21/2026</a:t>
+              <a:t>9/24/2026</a:t>
             </a:fld>
             <a:endParaRPr lang="en-US"/>
           </a:p>
@@ -9941,7 +10378,7 @@
             </a:r>
             <a:r>
               <a:rPr lang="en-US" dirty="0"/>
-              <a:t> application utilizes clean code principles:</a:t>
+              <a:t> application utilizes clean code principles. The code base is structured around separation of concerns and contains the following layers:</a:t>
             </a:r>
           </a:p>
           <a:p>
@@ -9954,7 +10391,7 @@
             </a:pPr>
             <a:r>
               <a:rPr lang="en-US" dirty="0"/>
-              <a:t>Api layer</a:t>
+              <a:t>Api layer: Interface and error handling. Calls service layer</a:t>
             </a:r>
           </a:p>
           <a:p>
@@ -9964,7 +10401,7 @@
             </a:pPr>
             <a:r>
               <a:rPr lang="en-US" dirty="0"/>
-              <a:t>Service Layer</a:t>
+              <a:t>Service Layer: Business logic and logging. Calls persistence layer</a:t>
             </a:r>
           </a:p>
           <a:p>
@@ -9974,8 +10411,11 @@
             </a:pPr>
             <a:r>
               <a:rPr lang="en-US" dirty="0"/>
-              <a:t>Persistence Layer</a:t>
-            </a:r>
+              <a:t>Persistence Layer: Database Access Objects</a:t>
+            </a:r>
+          </a:p>
+          <a:p>
+            <a:endParaRPr lang="en-US" dirty="0"/>
           </a:p>
           <a:p>
             <a:pPr marL="285750" indent="-285750">
@@ -9984,101 +10424,16 @@
             </a:pPr>
             <a:r>
               <a:rPr lang="en-US" dirty="0"/>
-              <a:t>Domain Layer</a:t>
-            </a:r>
-          </a:p>
-        </p:txBody>
-      </p:sp>
-      <p:pic>
-        <p:nvPicPr>
-          <p:cNvPr id="5" name="Picture 4">
-            <a:extLst>
-              <a:ext uri="{FF2B5EF4-FFF2-40B4-BE49-F238E27FC236}">
-                <a16:creationId xmlns:a16="http://schemas.microsoft.com/office/drawing/2014/main" id="{40BF2BE5-3CE9-E460-AEB3-45966F7C5253}"/>
-              </a:ext>
-            </a:extLst>
-          </p:cNvPr>
-          <p:cNvPicPr>
-            <a:picLocks noChangeAspect="1"/>
-          </p:cNvPicPr>
-          <p:nvPr/>
-        </p:nvPicPr>
-        <p:blipFill>
-          <a:blip r:embed="rId2"/>
-          <a:stretch>
-            <a:fillRect/>
-          </a:stretch>
-        </p:blipFill>
-        <p:spPr>
-          <a:xfrm>
-            <a:off x="7074401" y="2175923"/>
-            <a:ext cx="4854361" cy="990686"/>
-          </a:xfrm>
-          <a:prstGeom prst="rect">
-            <a:avLst/>
-          </a:prstGeom>
-        </p:spPr>
-      </p:pic>
-      <p:pic>
-        <p:nvPicPr>
-          <p:cNvPr id="7" name="Picture 6">
-            <a:extLst>
-              <a:ext uri="{FF2B5EF4-FFF2-40B4-BE49-F238E27FC236}">
-                <a16:creationId xmlns:a16="http://schemas.microsoft.com/office/drawing/2014/main" id="{B8085F88-6CF9-1DF5-F844-1BD2F15727EA}"/>
-              </a:ext>
-            </a:extLst>
-          </p:cNvPr>
-          <p:cNvPicPr>
-            <a:picLocks noChangeAspect="1"/>
-          </p:cNvPicPr>
-          <p:nvPr/>
-        </p:nvPicPr>
-        <p:blipFill>
-          <a:blip r:embed="rId3"/>
-          <a:stretch>
-            <a:fillRect/>
-          </a:stretch>
-        </p:blipFill>
-        <p:spPr>
-          <a:xfrm>
-            <a:off x="6011333" y="3217410"/>
-            <a:ext cx="6046823" cy="1932490"/>
-          </a:xfrm>
-          <a:prstGeom prst="rect">
-            <a:avLst/>
-          </a:prstGeom>
-        </p:spPr>
-      </p:pic>
-      <p:pic>
-        <p:nvPicPr>
-          <p:cNvPr id="9" name="Picture 8">
-            <a:extLst>
-              <a:ext uri="{FF2B5EF4-FFF2-40B4-BE49-F238E27FC236}">
-                <a16:creationId xmlns:a16="http://schemas.microsoft.com/office/drawing/2014/main" id="{8403976B-0D7F-8F1B-5C36-2747E725454F}"/>
-              </a:ext>
-            </a:extLst>
-          </p:cNvPr>
-          <p:cNvPicPr>
-            <a:picLocks noChangeAspect="1"/>
-          </p:cNvPicPr>
-          <p:nvPr/>
-        </p:nvPicPr>
-        <p:blipFill>
-          <a:blip r:embed="rId4"/>
-          <a:stretch>
-            <a:fillRect/>
-          </a:stretch>
-        </p:blipFill>
-        <p:spPr>
-          <a:xfrm>
-            <a:off x="3355362" y="5200701"/>
-            <a:ext cx="8702794" cy="853514"/>
-          </a:xfrm>
-          <a:prstGeom prst="rect">
-            <a:avLst/>
-          </a:prstGeom>
-        </p:spPr>
-      </p:pic>
+              <a:t>Domain Layer: Object Definitions. Provides </a:t>
+            </a:r>
+            <a:r>
+              <a:rPr lang="en-US"/>
+              <a:t>general structure to every layer.</a:t>
+            </a:r>
+            <a:endParaRPr lang="en-US" dirty="0"/>
+          </a:p>
+        </p:txBody>
+      </p:sp>
     </p:spTree>
     <p:extLst>
       <p:ext uri="{BB962C8B-B14F-4D97-AF65-F5344CB8AC3E}">
@@ -10160,7 +10515,22 @@
           <a:p>
             <a:r>
               <a:rPr lang="en-US" dirty="0"/>
-              <a:t>Unit testing is done using Junit, Jupiter, and Mockito</a:t>
+              <a:t>Unit testing is done using Junit. Jupiter and Mockito exist to help test in a void.</a:t>
+            </a:r>
+          </a:p>
+          <a:p>
+            <a:r>
+              <a:rPr lang="en-US" dirty="0"/>
+              <a:t>Unit test goes over the service layer to ensure any input results in an expected output</a:t>
+            </a:r>
+          </a:p>
+          <a:p>
+            <a:endParaRPr lang="en-US" dirty="0"/>
+          </a:p>
+          <a:p>
+            <a:r>
+              <a:rPr lang="en-US" dirty="0"/>
+              <a:t>Positive test to ensure the function works, negative tests to ensure graceful error handling.</a:t>
             </a:r>
           </a:p>
           <a:p>
@@ -10177,36 +10547,6 @@
             <a:extLst>
               <a:ext uri="{FF2B5EF4-FFF2-40B4-BE49-F238E27FC236}">
                 <a16:creationId xmlns:a16="http://schemas.microsoft.com/office/drawing/2014/main" id="{D303D894-8A6F-7FDF-7840-69E62BB0B6D7}"/>
-              </a:ext>
-            </a:extLst>
-          </p:cNvPr>
-          <p:cNvPicPr>
-            <a:picLocks noChangeAspect="1"/>
-          </p:cNvPicPr>
-          <p:nvPr/>
-        </p:nvPicPr>
-        <p:blipFill>
-          <a:blip r:embed="rId2"/>
-          <a:stretch>
-            <a:fillRect/>
-          </a:stretch>
-        </p:blipFill>
-        <p:spPr>
-          <a:xfrm>
-            <a:off x="1316734" y="4602191"/>
-            <a:ext cx="3535318" cy="1980433"/>
-          </a:xfrm>
-          <a:prstGeom prst="rect">
-            <a:avLst/>
-          </a:prstGeom>
-        </p:spPr>
-      </p:pic>
-      <p:pic>
-        <p:nvPicPr>
-          <p:cNvPr id="7" name="Picture 6">
-            <a:extLst>
-              <a:ext uri="{FF2B5EF4-FFF2-40B4-BE49-F238E27FC236}">
-                <a16:creationId xmlns:a16="http://schemas.microsoft.com/office/drawing/2014/main" id="{6E1429B8-2710-74B3-5469-199F271C843E}"/>
               </a:ext>
             </a:extLst>
           </p:cNvPr>
@@ -10223,8 +10563,8 @@
         </p:blipFill>
         <p:spPr>
           <a:xfrm>
-            <a:off x="6096000" y="4334665"/>
-            <a:ext cx="4228933" cy="2515486"/>
+            <a:off x="173734" y="4735328"/>
+            <a:ext cx="3535318" cy="1980433"/>
           </a:xfrm>
           <a:prstGeom prst="rect">
             <a:avLst/>
@@ -10233,10 +10573,10 @@
       </p:pic>
       <p:pic>
         <p:nvPicPr>
-          <p:cNvPr id="9" name="Picture 8">
-            <a:extLst>
-              <a:ext uri="{FF2B5EF4-FFF2-40B4-BE49-F238E27FC236}">
-                <a16:creationId xmlns:a16="http://schemas.microsoft.com/office/drawing/2014/main" id="{44B77AFC-89AF-4DDE-B075-3E19DDDBCDA7}"/>
+          <p:cNvPr id="7" name="Picture 6">
+            <a:extLst>
+              <a:ext uri="{FF2B5EF4-FFF2-40B4-BE49-F238E27FC236}">
+                <a16:creationId xmlns:a16="http://schemas.microsoft.com/office/drawing/2014/main" id="{6E1429B8-2710-74B3-5469-199F271C843E}"/>
               </a:ext>
             </a:extLst>
           </p:cNvPr>
@@ -10253,8 +10593,38 @@
         </p:blipFill>
         <p:spPr>
           <a:xfrm>
-            <a:off x="1484900" y="2382599"/>
-            <a:ext cx="7666795" cy="1884754"/>
+            <a:off x="8576733" y="4723651"/>
+            <a:ext cx="3415361" cy="2031551"/>
+          </a:xfrm>
+          <a:prstGeom prst="rect">
+            <a:avLst/>
+          </a:prstGeom>
+        </p:spPr>
+      </p:pic>
+      <p:pic>
+        <p:nvPicPr>
+          <p:cNvPr id="6" name="Picture 5">
+            <a:extLst>
+              <a:ext uri="{FF2B5EF4-FFF2-40B4-BE49-F238E27FC236}">
+                <a16:creationId xmlns:a16="http://schemas.microsoft.com/office/drawing/2014/main" id="{88F4E8F0-D803-E8DA-B5D5-4BB2BCCCD295}"/>
+              </a:ext>
+            </a:extLst>
+          </p:cNvPr>
+          <p:cNvPicPr>
+            <a:picLocks noChangeAspect="1"/>
+          </p:cNvPicPr>
+          <p:nvPr/>
+        </p:nvPicPr>
+        <p:blipFill>
+          <a:blip r:embed="rId5"/>
+          <a:stretch>
+            <a:fillRect/>
+          </a:stretch>
+        </p:blipFill>
+        <p:spPr>
+          <a:xfrm>
+            <a:off x="2137635" y="3244344"/>
+            <a:ext cx="7916729" cy="1490984"/>
           </a:xfrm>
           <a:prstGeom prst="rect">
             <a:avLst/>
@@ -10353,6 +10723,15 @@
               <a:t> to notify of database loss.</a:t>
             </a:r>
           </a:p>
+          <a:p>
+            <a:endParaRPr lang="en-US" dirty="0"/>
+          </a:p>
+          <a:p>
+            <a:r>
+              <a:rPr lang="en-US" dirty="0"/>
+              <a:t>This allows us to track user behavior and where sources of error may be happening.</a:t>
+            </a:r>
+          </a:p>
         </p:txBody>
       </p:sp>
       <p:pic>
@@ -10377,8 +10756,8 @@
         </p:blipFill>
         <p:spPr>
           <a:xfrm>
-            <a:off x="1088134" y="2671266"/>
-            <a:ext cx="7948349" cy="1181202"/>
+            <a:off x="1088134" y="3569227"/>
+            <a:ext cx="9938151" cy="1476906"/>
           </a:xfrm>
           <a:prstGeom prst="rect">
             <a:avLst/>
@@ -10407,8 +10786,8 @@
         </p:blipFill>
         <p:spPr>
           <a:xfrm>
-            <a:off x="1088134" y="4159828"/>
-            <a:ext cx="7750212" cy="228620"/>
+            <a:off x="1088134" y="5954761"/>
+            <a:ext cx="9954354" cy="293639"/>
           </a:xfrm>
           <a:prstGeom prst="rect">
             <a:avLst/>
@@ -10419,6 +10798,92 @@
     <p:extLst>
       <p:ext uri="{BB962C8B-B14F-4D97-AF65-F5344CB8AC3E}">
         <p14:creationId xmlns:p14="http://schemas.microsoft.com/office/powerpoint/2010/main" val="1135717389"/>
+      </p:ext>
+    </p:extLst>
+  </p:cSld>
+  <p:clrMapOvr>
+    <a:masterClrMapping/>
+  </p:clrMapOvr>
+</p:sld>
+</file>
+
+<file path=ppt/slides/slide5.xml><?xml version="1.0" encoding="utf-8"?>
+<p:sld xmlns:a="http://schemas.openxmlformats.org/drawingml/2006/main" xmlns:r="http://schemas.openxmlformats.org/officeDocument/2006/relationships" xmlns:p="http://schemas.openxmlformats.org/presentationml/2006/main">
+  <p:cSld>
+    <p:spTree>
+      <p:nvGrpSpPr>
+        <p:cNvPr id="1" name=""/>
+        <p:cNvGrpSpPr/>
+        <p:nvPr/>
+      </p:nvGrpSpPr>
+      <p:grpSpPr>
+        <a:xfrm>
+          <a:off x="0" y="0"/>
+          <a:ext cx="0" cy="0"/>
+          <a:chOff x="0" y="0"/>
+          <a:chExt cx="0" cy="0"/>
+        </a:xfrm>
+      </p:grpSpPr>
+      <p:sp>
+        <p:nvSpPr>
+          <p:cNvPr id="2" name="Title 1">
+            <a:extLst>
+              <a:ext uri="{FF2B5EF4-FFF2-40B4-BE49-F238E27FC236}">
+                <a16:creationId xmlns:a16="http://schemas.microsoft.com/office/drawing/2014/main" id="{3C0BE962-C88C-83FA-E6DB-644EB5DB620C}"/>
+              </a:ext>
+            </a:extLst>
+          </p:cNvPr>
+          <p:cNvSpPr>
+            <a:spLocks noGrp="1"/>
+          </p:cNvSpPr>
+          <p:nvPr>
+            <p:ph type="title"/>
+          </p:nvPr>
+        </p:nvSpPr>
+        <p:spPr/>
+        <p:txBody>
+          <a:bodyPr/>
+          <a:lstStyle/>
+          <a:p>
+            <a:r>
+              <a:rPr lang="en-US" dirty="0"/>
+              <a:t>Demo</a:t>
+            </a:r>
+          </a:p>
+        </p:txBody>
+      </p:sp>
+      <p:sp>
+        <p:nvSpPr>
+          <p:cNvPr id="3" name="Content Placeholder 2">
+            <a:extLst>
+              <a:ext uri="{FF2B5EF4-FFF2-40B4-BE49-F238E27FC236}">
+                <a16:creationId xmlns:a16="http://schemas.microsoft.com/office/drawing/2014/main" id="{3C9F786C-53AB-9BB0-D6A6-01177B41AF8C}"/>
+              </a:ext>
+            </a:extLst>
+          </p:cNvPr>
+          <p:cNvSpPr>
+            <a:spLocks noGrp="1"/>
+          </p:cNvSpPr>
+          <p:nvPr>
+            <p:ph idx="1"/>
+          </p:nvPr>
+        </p:nvSpPr>
+        <p:spPr/>
+        <p:txBody>
+          <a:bodyPr/>
+          <a:lstStyle/>
+          <a:p>
+            <a:r>
+              <a:rPr lang="en-US" dirty="0"/>
+              <a:t>To show the functions and how the application works, let’s move into the demo.</a:t>
+            </a:r>
+          </a:p>
+        </p:txBody>
+      </p:sp>
+    </p:spTree>
+    <p:extLst>
+      <p:ext uri="{BB962C8B-B14F-4D97-AF65-F5344CB8AC3E}">
+        <p14:creationId xmlns:p14="http://schemas.microsoft.com/office/powerpoint/2010/main" val="314795595"/>
       </p:ext>
     </p:extLst>
   </p:cSld>
@@ -10627,4 +11092,319 @@
     </a:ext>
   </a:extLst>
 </a:theme>
+</file>
+
+<file path=ppt/theme/theme2.xml><?xml version="1.0" encoding="utf-8"?>
+<a:theme xmlns:a="http://schemas.openxmlformats.org/drawingml/2006/main" name="Office Theme">
+  <a:themeElements>
+    <a:clrScheme name="Office">
+      <a:dk1>
+        <a:sysClr val="windowText" lastClr="000000"/>
+      </a:dk1>
+      <a:lt1>
+        <a:sysClr val="window" lastClr="FFFFFF"/>
+      </a:lt1>
+      <a:dk2>
+        <a:srgbClr val="0E2841"/>
+      </a:dk2>
+      <a:lt2>
+        <a:srgbClr val="E8E8E8"/>
+      </a:lt2>
+      <a:accent1>
+        <a:srgbClr val="156082"/>
+      </a:accent1>
+      <a:accent2>
+        <a:srgbClr val="E97132"/>
+      </a:accent2>
+      <a:accent3>
+        <a:srgbClr val="196B24"/>
+      </a:accent3>
+      <a:accent4>
+        <a:srgbClr val="0F9ED5"/>
+      </a:accent4>
+      <a:accent5>
+        <a:srgbClr val="A02B93"/>
+      </a:accent5>
+      <a:accent6>
+        <a:srgbClr val="4EA72E"/>
+      </a:accent6>
+      <a:hlink>
+        <a:srgbClr val="467886"/>
+      </a:hlink>
+      <a:folHlink>
+        <a:srgbClr val="96607D"/>
+      </a:folHlink>
+    </a:clrScheme>
+    <a:fontScheme name="Office">
+      <a:majorFont>
+        <a:latin typeface="Aptos Display" panose="02110004020202020204"/>
+        <a:ea typeface=""/>
+        <a:cs typeface=""/>
+        <a:font script="Jpan" typeface="游ゴシック Light"/>
+        <a:font script="Hang" typeface="맑은 고딕"/>
+        <a:font script="Hans" typeface="等线 Light"/>
+        <a:font script="Hant" typeface="新細明體"/>
+        <a:font script="Arab" typeface="Times New Roman"/>
+        <a:font script="Hebr" typeface="Times New Roman"/>
+        <a:font script="Thai" typeface="Angsana New"/>
+        <a:font script="Ethi" typeface="Nyala"/>
+        <a:font script="Beng" typeface="Vrinda"/>
+        <a:font script="Gujr" typeface="Shruti"/>
+        <a:font script="Khmr" typeface="MoolBoran"/>
+        <a:font script="Knda" typeface="Tunga"/>
+        <a:font script="Guru" typeface="Raavi"/>
+        <a:font script="Cans" typeface="Euphemia"/>
+        <a:font script="Cher" typeface="Plantagenet Cherokee"/>
+        <a:font script="Yiii" typeface="Microsoft Yi Baiti"/>
+        <a:font script="Tibt" typeface="Microsoft Himalaya"/>
+        <a:font script="Thaa" typeface="MV Boli"/>
+        <a:font script="Deva" typeface="Mangal"/>
+        <a:font script="Telu" typeface="Gautami"/>
+        <a:font script="Taml" typeface="Latha"/>
+        <a:font script="Syrc" typeface="Estrangelo Edessa"/>
+        <a:font script="Orya" typeface="Kalinga"/>
+        <a:font script="Mlym" typeface="Kartika"/>
+        <a:font script="Laoo" typeface="DokChampa"/>
+        <a:font script="Sinh" typeface="Iskoola Pota"/>
+        <a:font script="Mong" typeface="Mongolian Baiti"/>
+        <a:font script="Viet" typeface="Times New Roman"/>
+        <a:font script="Uigh" typeface="Microsoft Uighur"/>
+        <a:font script="Geor" typeface="Sylfaen"/>
+        <a:font script="Armn" typeface="Arial"/>
+        <a:font script="Bugi" typeface="Leelawadee UI"/>
+        <a:font script="Bopo" typeface="Microsoft JhengHei"/>
+        <a:font script="Java" typeface="Javanese Text"/>
+        <a:font script="Lisu" typeface="Segoe UI"/>
+        <a:font script="Mymr" typeface="Myanmar Text"/>
+        <a:font script="Nkoo" typeface="Ebrima"/>
+        <a:font script="Olck" typeface="Nirmala UI"/>
+        <a:font script="Osma" typeface="Ebrima"/>
+        <a:font script="Phag" typeface="Phagspa"/>
+        <a:font script="Syrn" typeface="Estrangelo Edessa"/>
+        <a:font script="Syrj" typeface="Estrangelo Edessa"/>
+        <a:font script="Syre" typeface="Estrangelo Edessa"/>
+        <a:font script="Sora" typeface="Nirmala UI"/>
+        <a:font script="Tale" typeface="Microsoft Tai Le"/>
+        <a:font script="Talu" typeface="Microsoft New Tai Lue"/>
+        <a:font script="Tfng" typeface="Ebrima"/>
+      </a:majorFont>
+      <a:minorFont>
+        <a:latin typeface="Aptos" panose="02110004020202020204"/>
+        <a:ea typeface=""/>
+        <a:cs typeface=""/>
+        <a:font script="Jpan" typeface="游ゴシック"/>
+        <a:font script="Hang" typeface="맑은 고딕"/>
+        <a:font script="Hans" typeface="等线"/>
+        <a:font script="Hant" typeface="新細明體"/>
+        <a:font script="Arab" typeface="Arial"/>
+        <a:font script="Hebr" typeface="Arial"/>
+        <a:font script="Thai" typeface="Cordia New"/>
+        <a:font script="Ethi" typeface="Nyala"/>
+        <a:font script="Beng" typeface="Vrinda"/>
+        <a:font script="Gujr" typeface="Shruti"/>
+        <a:font script="Khmr" typeface="DaunPenh"/>
+        <a:font script="Knda" typeface="Tunga"/>
+        <a:font script="Guru" typeface="Raavi"/>
+        <a:font script="Cans" typeface="Euphemia"/>
+        <a:font script="Cher" typeface="Plantagenet Cherokee"/>
+        <a:font script="Yiii" typeface="Microsoft Yi Baiti"/>
+        <a:font script="Tibt" typeface="Microsoft Himalaya"/>
+        <a:font script="Thaa" typeface="MV Boli"/>
+        <a:font script="Deva" typeface="Mangal"/>
+        <a:font script="Telu" typeface="Gautami"/>
+        <a:font script="Taml" typeface="Latha"/>
+        <a:font script="Syrc" typeface="Estrangelo Edessa"/>
+        <a:font script="Orya" typeface="Kalinga"/>
+        <a:font script="Mlym" typeface="Kartika"/>
+        <a:font script="Laoo" typeface="DokChampa"/>
+        <a:font script="Sinh" typeface="Iskoola Pota"/>
+        <a:font script="Mong" typeface="Mongolian Baiti"/>
+        <a:font script="Viet" typeface="Arial"/>
+        <a:font script="Uigh" typeface="Microsoft Uighur"/>
+        <a:font script="Geor" typeface="Sylfaen"/>
+        <a:font script="Armn" typeface="Arial"/>
+        <a:font script="Bugi" typeface="Leelawadee UI"/>
+        <a:font script="Bopo" typeface="Microsoft JhengHei"/>
+        <a:font script="Java" typeface="Javanese Text"/>
+        <a:font script="Lisu" typeface="Segoe UI"/>
+        <a:font script="Mymr" typeface="Myanmar Text"/>
+        <a:font script="Nkoo" typeface="Ebrima"/>
+        <a:font script="Olck" typeface="Nirmala UI"/>
+        <a:font script="Osma" typeface="Ebrima"/>
+        <a:font script="Phag" typeface="Phagspa"/>
+        <a:font script="Syrn" typeface="Estrangelo Edessa"/>
+        <a:font script="Syrj" typeface="Estrangelo Edessa"/>
+        <a:font script="Syre" typeface="Estrangelo Edessa"/>
+        <a:font script="Sora" typeface="Nirmala UI"/>
+        <a:font script="Tale" typeface="Microsoft Tai Le"/>
+        <a:font script="Talu" typeface="Microsoft New Tai Lue"/>
+        <a:font script="Tfng" typeface="Ebrima"/>
+      </a:minorFont>
+    </a:fontScheme>
+    <a:fmtScheme name="Office">
+      <a:fillStyleLst>
+        <a:solidFill>
+          <a:schemeClr val="phClr"/>
+        </a:solidFill>
+        <a:gradFill rotWithShape="1">
+          <a:gsLst>
+            <a:gs pos="0">
+              <a:schemeClr val="phClr">
+                <a:lumMod val="110000"/>
+                <a:satMod val="105000"/>
+                <a:tint val="67000"/>
+              </a:schemeClr>
+            </a:gs>
+            <a:gs pos="50000">
+              <a:schemeClr val="phClr">
+                <a:lumMod val="105000"/>
+                <a:satMod val="103000"/>
+                <a:tint val="73000"/>
+              </a:schemeClr>
+            </a:gs>
+            <a:gs pos="100000">
+              <a:schemeClr val="phClr">
+                <a:lumMod val="105000"/>
+                <a:satMod val="109000"/>
+                <a:tint val="81000"/>
+              </a:schemeClr>
+            </a:gs>
+          </a:gsLst>
+          <a:lin ang="5400000" scaled="0"/>
+        </a:gradFill>
+        <a:gradFill rotWithShape="1">
+          <a:gsLst>
+            <a:gs pos="0">
+              <a:schemeClr val="phClr">
+                <a:satMod val="103000"/>
+                <a:lumMod val="102000"/>
+                <a:tint val="94000"/>
+              </a:schemeClr>
+            </a:gs>
+            <a:gs pos="50000">
+              <a:schemeClr val="phClr">
+                <a:satMod val="110000"/>
+                <a:lumMod val="100000"/>
+                <a:shade val="100000"/>
+              </a:schemeClr>
+            </a:gs>
+            <a:gs pos="100000">
+              <a:schemeClr val="phClr">
+                <a:lumMod val="99000"/>
+                <a:satMod val="120000"/>
+                <a:shade val="78000"/>
+              </a:schemeClr>
+            </a:gs>
+          </a:gsLst>
+          <a:lin ang="5400000" scaled="0"/>
+        </a:gradFill>
+      </a:fillStyleLst>
+      <a:lnStyleLst>
+        <a:ln w="12700" cap="flat" cmpd="sng" algn="ctr">
+          <a:solidFill>
+            <a:schemeClr val="phClr"/>
+          </a:solidFill>
+          <a:prstDash val="solid"/>
+          <a:miter lim="800000"/>
+        </a:ln>
+        <a:ln w="19050" cap="flat" cmpd="sng" algn="ctr">
+          <a:solidFill>
+            <a:schemeClr val="phClr"/>
+          </a:solidFill>
+          <a:prstDash val="solid"/>
+          <a:miter lim="800000"/>
+        </a:ln>
+        <a:ln w="25400" cap="flat" cmpd="sng" algn="ctr">
+          <a:solidFill>
+            <a:schemeClr val="phClr"/>
+          </a:solidFill>
+          <a:prstDash val="solid"/>
+          <a:miter lim="800000"/>
+        </a:ln>
+      </a:lnStyleLst>
+      <a:effectStyleLst>
+        <a:effectStyle>
+          <a:effectLst/>
+        </a:effectStyle>
+        <a:effectStyle>
+          <a:effectLst/>
+        </a:effectStyle>
+        <a:effectStyle>
+          <a:effectLst>
+            <a:outerShdw blurRad="57150" dist="19050" dir="5400000" algn="ctr" rotWithShape="0">
+              <a:srgbClr val="000000">
+                <a:alpha val="63000"/>
+              </a:srgbClr>
+            </a:outerShdw>
+          </a:effectLst>
+        </a:effectStyle>
+      </a:effectStyleLst>
+      <a:bgFillStyleLst>
+        <a:solidFill>
+          <a:schemeClr val="phClr"/>
+        </a:solidFill>
+        <a:solidFill>
+          <a:schemeClr val="phClr">
+            <a:tint val="95000"/>
+            <a:satMod val="170000"/>
+          </a:schemeClr>
+        </a:solidFill>
+        <a:gradFill rotWithShape="1">
+          <a:gsLst>
+            <a:gs pos="0">
+              <a:schemeClr val="phClr">
+                <a:tint val="93000"/>
+                <a:satMod val="150000"/>
+                <a:shade val="98000"/>
+                <a:lumMod val="102000"/>
+              </a:schemeClr>
+            </a:gs>
+            <a:gs pos="50000">
+              <a:schemeClr val="phClr">
+                <a:tint val="98000"/>
+                <a:satMod val="130000"/>
+                <a:shade val="90000"/>
+                <a:lumMod val="103000"/>
+              </a:schemeClr>
+            </a:gs>
+            <a:gs pos="100000">
+              <a:schemeClr val="phClr">
+                <a:shade val="63000"/>
+                <a:satMod val="120000"/>
+              </a:schemeClr>
+            </a:gs>
+          </a:gsLst>
+          <a:lin ang="5400000" scaled="0"/>
+        </a:gradFill>
+      </a:bgFillStyleLst>
+    </a:fmtScheme>
+  </a:themeElements>
+  <a:objectDefaults>
+    <a:lnDef>
+      <a:spPr/>
+      <a:bodyPr/>
+      <a:lstStyle/>
+      <a:style>
+        <a:lnRef idx="2">
+          <a:schemeClr val="accent1"/>
+        </a:lnRef>
+        <a:fillRef idx="0">
+          <a:schemeClr val="accent1"/>
+        </a:fillRef>
+        <a:effectRef idx="1">
+          <a:schemeClr val="accent1"/>
+        </a:effectRef>
+        <a:fontRef idx="minor">
+          <a:schemeClr val="tx1"/>
+        </a:fontRef>
+      </a:style>
+    </a:lnDef>
+  </a:objectDefaults>
+  <a:extraClrSchemeLst/>
+  <a:extLst>
+    <a:ext uri="{05A4C25C-085E-4340-85A3-A5531E510DB2}">
+      <thm15:themeFamily xmlns:thm15="http://schemas.microsoft.com/office/thememl/2012/main" name="Office Theme" id="{2E142A2C-CD16-42D6-873A-C26D2A0506FA}" vid="{1BDDFF52-6CD6-40A5-AB3C-68EB2F1E4D0A}"/>
+    </a:ext>
+  </a:extLst>
+</a:theme>
 </file>
</xml_diff>

<commit_message>
Updated presentation and how some values are displayed.
Todo:
- Maybe change money amount to BigInt to preserve proper rounding and follow best practice
- Maybe change PIN to String to allow for easier checking and allowing for starting with a zero
   - Might also just try and format PIN to allow for less than 4, so long as there is 1 non-zero character
- Add error handling and logging for SQL Exceptions inside service layer
   - Add warn instead of error inside all other business logic
   - Maybe add other exception types for different type of errors such that they are easier to test
- Once any more changes are made, add updates to presentation
</commit_message>
<xml_diff>
--- a/documents/Bank repl.pptx
+++ b/documents/Bank repl.pptx
@@ -5,14 +5,18 @@
     <p:sldMasterId id="2147483660" r:id="rId1"/>
   </p:sldMasterIdLst>
   <p:notesMasterIdLst>
-    <p:notesMasterId r:id="rId7"/>
+    <p:notesMasterId r:id="rId11"/>
   </p:notesMasterIdLst>
   <p:sldIdLst>
     <p:sldId id="256" r:id="rId2"/>
-    <p:sldId id="258" r:id="rId3"/>
-    <p:sldId id="259" r:id="rId4"/>
-    <p:sldId id="260" r:id="rId5"/>
-    <p:sldId id="261" r:id="rId6"/>
+    <p:sldId id="262" r:id="rId3"/>
+    <p:sldId id="258" r:id="rId4"/>
+    <p:sldId id="263" r:id="rId5"/>
+    <p:sldId id="264" r:id="rId6"/>
+    <p:sldId id="265" r:id="rId7"/>
+    <p:sldId id="259" r:id="rId8"/>
+    <p:sldId id="260" r:id="rId9"/>
+    <p:sldId id="261" r:id="rId10"/>
   </p:sldIdLst>
   <p:sldSz cx="12192000" cy="6858000"/>
   <p:notesSz cx="6858000" cy="9144000"/>
@@ -588,7 +592,7 @@
           <a:bodyPr/>
           <a:lstStyle/>
           <a:p>
-            <a:endParaRPr lang="en-US"/>
+            <a:endParaRPr lang="en-US" dirty="0"/>
           </a:p>
         </p:txBody>
       </p:sp>
@@ -609,7 +613,7 @@
           <a:p>
             <a:fld id="{78D4AC4A-0267-4A53-9FBB-82E7EAC6F562}" type="slidenum">
               <a:rPr lang="en-US" smtClean="0"/>
-              <a:t>3</a:t>
+              <a:t>7</a:t>
             </a:fld>
             <a:endParaRPr lang="en-US"/>
           </a:p>
@@ -10324,7 +10328,7 @@
           <p:cNvPr id="2" name="Title 1">
             <a:extLst>
               <a:ext uri="{FF2B5EF4-FFF2-40B4-BE49-F238E27FC236}">
-                <a16:creationId xmlns:a16="http://schemas.microsoft.com/office/drawing/2014/main" id="{625ABF17-CD03-ABB5-BF92-51FABE0CD950}"/>
+                <a16:creationId xmlns:a16="http://schemas.microsoft.com/office/drawing/2014/main" id="{AF598AC6-B4DE-D44D-4304-1CD491C8B890}"/>
               </a:ext>
             </a:extLst>
           </p:cNvPr>
@@ -10342,7 +10346,7 @@
           <a:p>
             <a:r>
               <a:rPr lang="en-US" dirty="0"/>
-              <a:t>Multilayer</a:t>
+              <a:t>Main function</a:t>
             </a:r>
           </a:p>
         </p:txBody>
@@ -10352,7 +10356,7 @@
           <p:cNvPr id="3" name="Content Placeholder 2">
             <a:extLst>
               <a:ext uri="{FF2B5EF4-FFF2-40B4-BE49-F238E27FC236}">
-                <a16:creationId xmlns:a16="http://schemas.microsoft.com/office/drawing/2014/main" id="{E2A9D020-9E8E-97CE-9E23-5BD158B427A9}"/>
+                <a16:creationId xmlns:a16="http://schemas.microsoft.com/office/drawing/2014/main" id="{E230679C-55BA-3253-72A4-FE916273A7BC}"/>
               </a:ext>
             </a:extLst>
           </p:cNvPr>
@@ -10369,75 +10373,64 @@
           <a:lstStyle/>
           <a:p>
             <a:r>
-              <a:rPr lang="en-US" dirty="0"/>
-              <a:t>This bank </a:t>
-            </a:r>
-            <a:r>
-              <a:rPr lang="en-US" dirty="0" err="1"/>
-              <a:t>repl</a:t>
-            </a:r>
-            <a:r>
-              <a:rPr lang="en-US" dirty="0"/>
-              <a:t> application utilizes clean code principles. The code base is structured around separation of concerns and contains the following layers:</a:t>
+              <a:rPr lang="en-US" sz="1800" dirty="0"/>
+              <a:t>This is a simplified bank application.</a:t>
             </a:r>
           </a:p>
           <a:p>
             <a:endParaRPr lang="en-US" dirty="0"/>
           </a:p>
           <a:p>
-            <a:pPr marL="285750" indent="-285750">
-              <a:buFontTx/>
-              <a:buChar char="-"/>
-            </a:pPr>
-            <a:r>
-              <a:rPr lang="en-US" dirty="0"/>
-              <a:t>Api layer: Interface and error handling. Calls service layer</a:t>
-            </a:r>
-          </a:p>
-          <a:p>
-            <a:pPr marL="285750" indent="-285750">
-              <a:buFontTx/>
-              <a:buChar char="-"/>
-            </a:pPr>
-            <a:r>
-              <a:rPr lang="en-US" dirty="0"/>
-              <a:t>Service Layer: Business logic and logging. Calls persistence layer</a:t>
-            </a:r>
-          </a:p>
-          <a:p>
-            <a:pPr marL="285750" indent="-285750">
-              <a:buFontTx/>
-              <a:buChar char="-"/>
-            </a:pPr>
-            <a:r>
-              <a:rPr lang="en-US" dirty="0"/>
-              <a:t>Persistence Layer: Database Access Objects</a:t>
+            <a:r>
+              <a:rPr lang="en-US" sz="1800" dirty="0"/>
+              <a:t>Accounts have basic account management and can:</a:t>
             </a:r>
           </a:p>
           <a:p>
             <a:endParaRPr lang="en-US" dirty="0"/>
           </a:p>
           <a:p>
-            <a:pPr marL="285750" indent="-285750">
-              <a:buFontTx/>
-              <a:buChar char="-"/>
-            </a:pPr>
-            <a:r>
-              <a:rPr lang="en-US" dirty="0"/>
-              <a:t>Domain Layer: Object Definitions. Provides </a:t>
-            </a:r>
-            <a:r>
-              <a:rPr lang="en-US"/>
-              <a:t>general structure to every layer.</a:t>
-            </a:r>
+            <a:r>
+              <a:rPr lang="en-US" dirty="0">
+                <a:solidFill>
+                  <a:schemeClr val="tx2">
+                    <a:lumMod val="75000"/>
+                  </a:schemeClr>
+                </a:solidFill>
+              </a:rPr>
+              <a:t>Create account				Login				View History</a:t>
+            </a:r>
+          </a:p>
+          <a:p>
             <a:endParaRPr lang="en-US" dirty="0"/>
+          </a:p>
+          <a:p>
+            <a:r>
+              <a:rPr lang="en-US" sz="1800" dirty="0"/>
+              <a:t>Accounts can do transaction actions:</a:t>
+            </a:r>
+          </a:p>
+          <a:p>
+            <a:endParaRPr lang="en-US" dirty="0"/>
+          </a:p>
+          <a:p>
+            <a:r>
+              <a:rPr lang="en-US" dirty="0">
+                <a:solidFill>
+                  <a:schemeClr val="tx2">
+                    <a:lumMod val="75000"/>
+                  </a:schemeClr>
+                </a:solidFill>
+              </a:rPr>
+              <a:t>Deposit					Withdraw				Transfer</a:t>
+            </a:r>
           </a:p>
         </p:txBody>
       </p:sp>
     </p:spTree>
     <p:extLst>
       <p:ext uri="{BB962C8B-B14F-4D97-AF65-F5344CB8AC3E}">
-        <p14:creationId xmlns:p14="http://schemas.microsoft.com/office/powerpoint/2010/main" val="910117835"/>
+        <p14:creationId xmlns:p14="http://schemas.microsoft.com/office/powerpoint/2010/main" val="1413264567"/>
       </p:ext>
     </p:extLst>
   </p:cSld>
@@ -10469,7 +10462,7 @@
           <p:cNvPr id="2" name="Title 1">
             <a:extLst>
               <a:ext uri="{FF2B5EF4-FFF2-40B4-BE49-F238E27FC236}">
-                <a16:creationId xmlns:a16="http://schemas.microsoft.com/office/drawing/2014/main" id="{D3A70AA7-6D8B-C828-05BC-80DD1F9573C8}"/>
+                <a16:creationId xmlns:a16="http://schemas.microsoft.com/office/drawing/2014/main" id="{625ABF17-CD03-ABB5-BF92-51FABE0CD950}"/>
               </a:ext>
             </a:extLst>
           </p:cNvPr>
@@ -10487,7 +10480,7 @@
           <a:p>
             <a:r>
               <a:rPr lang="en-US" dirty="0"/>
-              <a:t>Unit tests</a:t>
+              <a:t>Multilayer</a:t>
             </a:r>
           </a:p>
         </p:txBody>
@@ -10497,7 +10490,7 @@
           <p:cNvPr id="3" name="Content Placeholder 2">
             <a:extLst>
               <a:ext uri="{FF2B5EF4-FFF2-40B4-BE49-F238E27FC236}">
-                <a16:creationId xmlns:a16="http://schemas.microsoft.com/office/drawing/2014/main" id="{0F095763-55C9-5D2D-F40A-0CD17324E09C}"/>
+                <a16:creationId xmlns:a16="http://schemas.microsoft.com/office/drawing/2014/main" id="{E2A9D020-9E8E-97CE-9E23-5BD158B427A9}"/>
               </a:ext>
             </a:extLst>
           </p:cNvPr>
@@ -10515,126 +10508,69 @@
           <a:p>
             <a:r>
               <a:rPr lang="en-US" dirty="0"/>
-              <a:t>Unit testing is done using Junit. Jupiter and Mockito exist to help test in a void.</a:t>
-            </a:r>
-          </a:p>
-          <a:p>
+              <a:t>This bank </a:t>
+            </a:r>
+            <a:r>
+              <a:rPr lang="en-US" dirty="0" err="1"/>
+              <a:t>repl</a:t>
+            </a:r>
             <a:r>
               <a:rPr lang="en-US" dirty="0"/>
-              <a:t>Unit test goes over the service layer to ensure any input results in an expected output</a:t>
+              <a:t> application utilizes clean code principles. The code base is structured around separation of concerns and contains the following layers:</a:t>
             </a:r>
           </a:p>
           <a:p>
             <a:endParaRPr lang="en-US" dirty="0"/>
           </a:p>
           <a:p>
+            <a:pPr marL="285750" indent="-285750">
+              <a:buFontTx/>
+              <a:buChar char="-"/>
+            </a:pPr>
             <a:r>
               <a:rPr lang="en-US" dirty="0"/>
-              <a:t>Positive test to ensure the function works, negative tests to ensure graceful error handling.</a:t>
+              <a:t>Api layer: Interface and error handling. Calls service layer</a:t>
+            </a:r>
+          </a:p>
+          <a:p>
+            <a:pPr marL="285750" indent="-285750">
+              <a:buFontTx/>
+              <a:buChar char="-"/>
+            </a:pPr>
+            <a:r>
+              <a:rPr lang="en-US" dirty="0"/>
+              <a:t>Service Layer: Business logic and logging. Calls persistence layer</a:t>
+            </a:r>
+          </a:p>
+          <a:p>
+            <a:pPr marL="285750" indent="-285750">
+              <a:buFontTx/>
+              <a:buChar char="-"/>
+            </a:pPr>
+            <a:r>
+              <a:rPr lang="en-US" dirty="0"/>
+              <a:t>Persistence Layer: Database Access Objects</a:t>
             </a:r>
           </a:p>
           <a:p>
             <a:endParaRPr lang="en-US" dirty="0"/>
           </a:p>
           <a:p>
-            <a:endParaRPr lang="en-US" dirty="0"/>
-          </a:p>
-        </p:txBody>
-      </p:sp>
-      <p:pic>
-        <p:nvPicPr>
-          <p:cNvPr id="5" name="Picture 4">
-            <a:extLst>
-              <a:ext uri="{FF2B5EF4-FFF2-40B4-BE49-F238E27FC236}">
-                <a16:creationId xmlns:a16="http://schemas.microsoft.com/office/drawing/2014/main" id="{D303D894-8A6F-7FDF-7840-69E62BB0B6D7}"/>
-              </a:ext>
-            </a:extLst>
-          </p:cNvPr>
-          <p:cNvPicPr>
-            <a:picLocks noChangeAspect="1"/>
-          </p:cNvPicPr>
-          <p:nvPr/>
-        </p:nvPicPr>
-        <p:blipFill>
-          <a:blip r:embed="rId3"/>
-          <a:stretch>
-            <a:fillRect/>
-          </a:stretch>
-        </p:blipFill>
-        <p:spPr>
-          <a:xfrm>
-            <a:off x="173734" y="4735328"/>
-            <a:ext cx="3535318" cy="1980433"/>
-          </a:xfrm>
-          <a:prstGeom prst="rect">
-            <a:avLst/>
-          </a:prstGeom>
-        </p:spPr>
-      </p:pic>
-      <p:pic>
-        <p:nvPicPr>
-          <p:cNvPr id="7" name="Picture 6">
-            <a:extLst>
-              <a:ext uri="{FF2B5EF4-FFF2-40B4-BE49-F238E27FC236}">
-                <a16:creationId xmlns:a16="http://schemas.microsoft.com/office/drawing/2014/main" id="{6E1429B8-2710-74B3-5469-199F271C843E}"/>
-              </a:ext>
-            </a:extLst>
-          </p:cNvPr>
-          <p:cNvPicPr>
-            <a:picLocks noChangeAspect="1"/>
-          </p:cNvPicPr>
-          <p:nvPr/>
-        </p:nvPicPr>
-        <p:blipFill>
-          <a:blip r:embed="rId4"/>
-          <a:stretch>
-            <a:fillRect/>
-          </a:stretch>
-        </p:blipFill>
-        <p:spPr>
-          <a:xfrm>
-            <a:off x="8576733" y="4723651"/>
-            <a:ext cx="3415361" cy="2031551"/>
-          </a:xfrm>
-          <a:prstGeom prst="rect">
-            <a:avLst/>
-          </a:prstGeom>
-        </p:spPr>
-      </p:pic>
-      <p:pic>
-        <p:nvPicPr>
-          <p:cNvPr id="6" name="Picture 5">
-            <a:extLst>
-              <a:ext uri="{FF2B5EF4-FFF2-40B4-BE49-F238E27FC236}">
-                <a16:creationId xmlns:a16="http://schemas.microsoft.com/office/drawing/2014/main" id="{88F4E8F0-D803-E8DA-B5D5-4BB2BCCCD295}"/>
-              </a:ext>
-            </a:extLst>
-          </p:cNvPr>
-          <p:cNvPicPr>
-            <a:picLocks noChangeAspect="1"/>
-          </p:cNvPicPr>
-          <p:nvPr/>
-        </p:nvPicPr>
-        <p:blipFill>
-          <a:blip r:embed="rId5"/>
-          <a:stretch>
-            <a:fillRect/>
-          </a:stretch>
-        </p:blipFill>
-        <p:spPr>
-          <a:xfrm>
-            <a:off x="2137635" y="3244344"/>
-            <a:ext cx="7916729" cy="1490984"/>
-          </a:xfrm>
-          <a:prstGeom prst="rect">
-            <a:avLst/>
-          </a:prstGeom>
-        </p:spPr>
-      </p:pic>
+            <a:pPr marL="285750" indent="-285750">
+              <a:buFontTx/>
+              <a:buChar char="-"/>
+            </a:pPr>
+            <a:r>
+              <a:rPr lang="en-US" dirty="0"/>
+              <a:t>Domain Layer: Object Definitions. Provides general structure to every layer.</a:t>
+            </a:r>
+          </a:p>
+        </p:txBody>
+      </p:sp>
     </p:spTree>
     <p:extLst>
       <p:ext uri="{BB962C8B-B14F-4D97-AF65-F5344CB8AC3E}">
-        <p14:creationId xmlns:p14="http://schemas.microsoft.com/office/powerpoint/2010/main" val="3640341080"/>
+        <p14:creationId xmlns:p14="http://schemas.microsoft.com/office/powerpoint/2010/main" val="910117835"/>
       </p:ext>
     </p:extLst>
   </p:cSld>
@@ -10666,6 +10602,551 @@
           <p:cNvPr id="2" name="Title 1">
             <a:extLst>
               <a:ext uri="{FF2B5EF4-FFF2-40B4-BE49-F238E27FC236}">
+                <a16:creationId xmlns:a16="http://schemas.microsoft.com/office/drawing/2014/main" id="{C39128CF-3324-3088-CE2A-360D4E759614}"/>
+              </a:ext>
+            </a:extLst>
+          </p:cNvPr>
+          <p:cNvSpPr>
+            <a:spLocks noGrp="1"/>
+          </p:cNvSpPr>
+          <p:nvPr>
+            <p:ph type="title"/>
+          </p:nvPr>
+        </p:nvSpPr>
+        <p:spPr/>
+        <p:txBody>
+          <a:bodyPr/>
+          <a:lstStyle/>
+          <a:p>
+            <a:r>
+              <a:rPr lang="en-US" dirty="0"/>
+              <a:t>Api layer</a:t>
+            </a:r>
+          </a:p>
+        </p:txBody>
+      </p:sp>
+      <p:sp>
+        <p:nvSpPr>
+          <p:cNvPr id="3" name="Content Placeholder 2">
+            <a:extLst>
+              <a:ext uri="{FF2B5EF4-FFF2-40B4-BE49-F238E27FC236}">
+                <a16:creationId xmlns:a16="http://schemas.microsoft.com/office/drawing/2014/main" id="{9D5B317B-D86B-4ADE-FAFD-945699D34297}"/>
+              </a:ext>
+            </a:extLst>
+          </p:cNvPr>
+          <p:cNvSpPr>
+            <a:spLocks noGrp="1"/>
+          </p:cNvSpPr>
+          <p:nvPr>
+            <p:ph idx="1"/>
+          </p:nvPr>
+        </p:nvSpPr>
+        <p:spPr/>
+        <p:txBody>
+          <a:bodyPr/>
+          <a:lstStyle/>
+          <a:p>
+            <a:r>
+              <a:rPr lang="en-US" dirty="0"/>
+              <a:t>This layer is designed to output information from the user as well as getting user inputs and handling errors locally. Once valid shaped inputs are collected, send to the service layer.</a:t>
+            </a:r>
+          </a:p>
+        </p:txBody>
+      </p:sp>
+      <p:pic>
+        <p:nvPicPr>
+          <p:cNvPr id="5" name="Picture 4">
+            <a:extLst>
+              <a:ext uri="{FF2B5EF4-FFF2-40B4-BE49-F238E27FC236}">
+                <a16:creationId xmlns:a16="http://schemas.microsoft.com/office/drawing/2014/main" id="{E5E33D75-653C-BAA2-9CED-717F8666ED59}"/>
+              </a:ext>
+            </a:extLst>
+          </p:cNvPr>
+          <p:cNvPicPr>
+            <a:picLocks noChangeAspect="1"/>
+          </p:cNvPicPr>
+          <p:nvPr/>
+        </p:nvPicPr>
+        <p:blipFill>
+          <a:blip r:embed="rId2"/>
+          <a:stretch>
+            <a:fillRect/>
+          </a:stretch>
+        </p:blipFill>
+        <p:spPr>
+          <a:xfrm>
+            <a:off x="2742664" y="2993000"/>
+            <a:ext cx="6706672" cy="3767634"/>
+          </a:xfrm>
+          <a:prstGeom prst="rect">
+            <a:avLst/>
+          </a:prstGeom>
+        </p:spPr>
+      </p:pic>
+    </p:spTree>
+    <p:extLst>
+      <p:ext uri="{BB962C8B-B14F-4D97-AF65-F5344CB8AC3E}">
+        <p14:creationId xmlns:p14="http://schemas.microsoft.com/office/powerpoint/2010/main" val="1923491666"/>
+      </p:ext>
+    </p:extLst>
+  </p:cSld>
+  <p:clrMapOvr>
+    <a:masterClrMapping/>
+  </p:clrMapOvr>
+</p:sld>
+</file>
+
+<file path=ppt/slides/slide5.xml><?xml version="1.0" encoding="utf-8"?>
+<p:sld xmlns:a="http://schemas.openxmlformats.org/drawingml/2006/main" xmlns:r="http://schemas.openxmlformats.org/officeDocument/2006/relationships" xmlns:p="http://schemas.openxmlformats.org/presentationml/2006/main">
+  <p:cSld>
+    <p:spTree>
+      <p:nvGrpSpPr>
+        <p:cNvPr id="1" name=""/>
+        <p:cNvGrpSpPr/>
+        <p:nvPr/>
+      </p:nvGrpSpPr>
+      <p:grpSpPr>
+        <a:xfrm>
+          <a:off x="0" y="0"/>
+          <a:ext cx="0" cy="0"/>
+          <a:chOff x="0" y="0"/>
+          <a:chExt cx="0" cy="0"/>
+        </a:xfrm>
+      </p:grpSpPr>
+      <p:sp>
+        <p:nvSpPr>
+          <p:cNvPr id="2" name="Title 1">
+            <a:extLst>
+              <a:ext uri="{FF2B5EF4-FFF2-40B4-BE49-F238E27FC236}">
+                <a16:creationId xmlns:a16="http://schemas.microsoft.com/office/drawing/2014/main" id="{E55DFF9B-EC24-C183-32EC-2C48976AE6F3}"/>
+              </a:ext>
+            </a:extLst>
+          </p:cNvPr>
+          <p:cNvSpPr>
+            <a:spLocks noGrp="1"/>
+          </p:cNvSpPr>
+          <p:nvPr>
+            <p:ph type="title"/>
+          </p:nvPr>
+        </p:nvSpPr>
+        <p:spPr/>
+        <p:txBody>
+          <a:bodyPr/>
+          <a:lstStyle/>
+          <a:p>
+            <a:r>
+              <a:rPr lang="en-US" dirty="0"/>
+              <a:t>Service layer</a:t>
+            </a:r>
+          </a:p>
+        </p:txBody>
+      </p:sp>
+      <p:sp>
+        <p:nvSpPr>
+          <p:cNvPr id="3" name="Content Placeholder 2">
+            <a:extLst>
+              <a:ext uri="{FF2B5EF4-FFF2-40B4-BE49-F238E27FC236}">
+                <a16:creationId xmlns:a16="http://schemas.microsoft.com/office/drawing/2014/main" id="{2CDA2C3B-719A-FF62-96E4-0C8B93688865}"/>
+              </a:ext>
+            </a:extLst>
+          </p:cNvPr>
+          <p:cNvSpPr>
+            <a:spLocks noGrp="1"/>
+          </p:cNvSpPr>
+          <p:nvPr>
+            <p:ph idx="1"/>
+          </p:nvPr>
+        </p:nvSpPr>
+        <p:spPr/>
+        <p:txBody>
+          <a:bodyPr/>
+          <a:lstStyle/>
+          <a:p>
+            <a:r>
+              <a:rPr lang="en-US" dirty="0"/>
+              <a:t>Ensures that any business logic is followed. Prevents invalid data from entering the persistence layer. Sends human readable errors up to the API layer if there is a fault, otherwise moves to persistence. </a:t>
+            </a:r>
+          </a:p>
+        </p:txBody>
+      </p:sp>
+      <p:pic>
+        <p:nvPicPr>
+          <p:cNvPr id="7" name="Picture 6">
+            <a:extLst>
+              <a:ext uri="{FF2B5EF4-FFF2-40B4-BE49-F238E27FC236}">
+                <a16:creationId xmlns:a16="http://schemas.microsoft.com/office/drawing/2014/main" id="{FCB3BD4E-5A75-31F6-0466-383B846B5591}"/>
+              </a:ext>
+            </a:extLst>
+          </p:cNvPr>
+          <p:cNvPicPr>
+            <a:picLocks noChangeAspect="1"/>
+          </p:cNvPicPr>
+          <p:nvPr/>
+        </p:nvPicPr>
+        <p:blipFill>
+          <a:blip r:embed="rId2"/>
+          <a:stretch>
+            <a:fillRect/>
+          </a:stretch>
+        </p:blipFill>
+        <p:spPr>
+          <a:xfrm>
+            <a:off x="2379168" y="2696667"/>
+            <a:ext cx="7433663" cy="4074286"/>
+          </a:xfrm>
+          <a:prstGeom prst="rect">
+            <a:avLst/>
+          </a:prstGeom>
+        </p:spPr>
+      </p:pic>
+    </p:spTree>
+    <p:extLst>
+      <p:ext uri="{BB962C8B-B14F-4D97-AF65-F5344CB8AC3E}">
+        <p14:creationId xmlns:p14="http://schemas.microsoft.com/office/powerpoint/2010/main" val="938655017"/>
+      </p:ext>
+    </p:extLst>
+  </p:cSld>
+  <p:clrMapOvr>
+    <a:masterClrMapping/>
+  </p:clrMapOvr>
+</p:sld>
+</file>
+
+<file path=ppt/slides/slide6.xml><?xml version="1.0" encoding="utf-8"?>
+<p:sld xmlns:a="http://schemas.openxmlformats.org/drawingml/2006/main" xmlns:r="http://schemas.openxmlformats.org/officeDocument/2006/relationships" xmlns:p="http://schemas.openxmlformats.org/presentationml/2006/main">
+  <p:cSld>
+    <p:spTree>
+      <p:nvGrpSpPr>
+        <p:cNvPr id="1" name=""/>
+        <p:cNvGrpSpPr/>
+        <p:nvPr/>
+      </p:nvGrpSpPr>
+      <p:grpSpPr>
+        <a:xfrm>
+          <a:off x="0" y="0"/>
+          <a:ext cx="0" cy="0"/>
+          <a:chOff x="0" y="0"/>
+          <a:chExt cx="0" cy="0"/>
+        </a:xfrm>
+      </p:grpSpPr>
+      <p:sp>
+        <p:nvSpPr>
+          <p:cNvPr id="2" name="Title 1">
+            <a:extLst>
+              <a:ext uri="{FF2B5EF4-FFF2-40B4-BE49-F238E27FC236}">
+                <a16:creationId xmlns:a16="http://schemas.microsoft.com/office/drawing/2014/main" id="{23A229AF-0E4C-98FF-785C-50B43CC02158}"/>
+              </a:ext>
+            </a:extLst>
+          </p:cNvPr>
+          <p:cNvSpPr>
+            <a:spLocks noGrp="1"/>
+          </p:cNvSpPr>
+          <p:nvPr>
+            <p:ph type="title"/>
+          </p:nvPr>
+        </p:nvSpPr>
+        <p:spPr/>
+        <p:txBody>
+          <a:bodyPr/>
+          <a:lstStyle/>
+          <a:p>
+            <a:r>
+              <a:rPr lang="en-US" dirty="0"/>
+              <a:t>Persistence layer</a:t>
+            </a:r>
+          </a:p>
+        </p:txBody>
+      </p:sp>
+      <p:sp>
+        <p:nvSpPr>
+          <p:cNvPr id="3" name="Content Placeholder 2">
+            <a:extLst>
+              <a:ext uri="{FF2B5EF4-FFF2-40B4-BE49-F238E27FC236}">
+                <a16:creationId xmlns:a16="http://schemas.microsoft.com/office/drawing/2014/main" id="{A7A9A5B1-0564-9455-6F85-63F6B80114DE}"/>
+              </a:ext>
+            </a:extLst>
+          </p:cNvPr>
+          <p:cNvSpPr>
+            <a:spLocks noGrp="1"/>
+          </p:cNvSpPr>
+          <p:nvPr>
+            <p:ph idx="1"/>
+          </p:nvPr>
+        </p:nvSpPr>
+        <p:spPr/>
+        <p:txBody>
+          <a:bodyPr/>
+          <a:lstStyle/>
+          <a:p>
+            <a:r>
+              <a:rPr lang="en-US" dirty="0"/>
+              <a:t>Uses prepared statements to talk to the database. Assumes that all data it receives will be valid. Enforces atomicity in it’s error handling.</a:t>
+            </a:r>
+          </a:p>
+        </p:txBody>
+      </p:sp>
+      <p:pic>
+        <p:nvPicPr>
+          <p:cNvPr id="5" name="Picture 4">
+            <a:extLst>
+              <a:ext uri="{FF2B5EF4-FFF2-40B4-BE49-F238E27FC236}">
+                <a16:creationId xmlns:a16="http://schemas.microsoft.com/office/drawing/2014/main" id="{7D06044D-1C80-E538-DDDB-2A4F7ACD3F65}"/>
+              </a:ext>
+            </a:extLst>
+          </p:cNvPr>
+          <p:cNvPicPr>
+            <a:picLocks noChangeAspect="1"/>
+          </p:cNvPicPr>
+          <p:nvPr/>
+        </p:nvPicPr>
+        <p:blipFill>
+          <a:blip r:embed="rId2"/>
+          <a:stretch>
+            <a:fillRect/>
+          </a:stretch>
+        </p:blipFill>
+        <p:spPr>
+          <a:xfrm>
+            <a:off x="2186540" y="2645865"/>
+            <a:ext cx="7818919" cy="4125320"/>
+          </a:xfrm>
+          <a:prstGeom prst="rect">
+            <a:avLst/>
+          </a:prstGeom>
+        </p:spPr>
+      </p:pic>
+    </p:spTree>
+    <p:extLst>
+      <p:ext uri="{BB962C8B-B14F-4D97-AF65-F5344CB8AC3E}">
+        <p14:creationId xmlns:p14="http://schemas.microsoft.com/office/powerpoint/2010/main" val="441885967"/>
+      </p:ext>
+    </p:extLst>
+  </p:cSld>
+  <p:clrMapOvr>
+    <a:masterClrMapping/>
+  </p:clrMapOvr>
+</p:sld>
+</file>
+
+<file path=ppt/slides/slide7.xml><?xml version="1.0" encoding="utf-8"?>
+<p:sld xmlns:a="http://schemas.openxmlformats.org/drawingml/2006/main" xmlns:r="http://schemas.openxmlformats.org/officeDocument/2006/relationships" xmlns:p="http://schemas.openxmlformats.org/presentationml/2006/main">
+  <p:cSld>
+    <p:spTree>
+      <p:nvGrpSpPr>
+        <p:cNvPr id="1" name=""/>
+        <p:cNvGrpSpPr/>
+        <p:nvPr/>
+      </p:nvGrpSpPr>
+      <p:grpSpPr>
+        <a:xfrm>
+          <a:off x="0" y="0"/>
+          <a:ext cx="0" cy="0"/>
+          <a:chOff x="0" y="0"/>
+          <a:chExt cx="0" cy="0"/>
+        </a:xfrm>
+      </p:grpSpPr>
+      <p:sp>
+        <p:nvSpPr>
+          <p:cNvPr id="2" name="Title 1">
+            <a:extLst>
+              <a:ext uri="{FF2B5EF4-FFF2-40B4-BE49-F238E27FC236}">
+                <a16:creationId xmlns:a16="http://schemas.microsoft.com/office/drawing/2014/main" id="{D3A70AA7-6D8B-C828-05BC-80DD1F9573C8}"/>
+              </a:ext>
+            </a:extLst>
+          </p:cNvPr>
+          <p:cNvSpPr>
+            <a:spLocks noGrp="1"/>
+          </p:cNvSpPr>
+          <p:nvPr>
+            <p:ph type="title"/>
+          </p:nvPr>
+        </p:nvSpPr>
+        <p:spPr/>
+        <p:txBody>
+          <a:bodyPr/>
+          <a:lstStyle/>
+          <a:p>
+            <a:r>
+              <a:rPr lang="en-US" dirty="0"/>
+              <a:t>Unit tests</a:t>
+            </a:r>
+          </a:p>
+        </p:txBody>
+      </p:sp>
+      <p:sp>
+        <p:nvSpPr>
+          <p:cNvPr id="3" name="Content Placeholder 2">
+            <a:extLst>
+              <a:ext uri="{FF2B5EF4-FFF2-40B4-BE49-F238E27FC236}">
+                <a16:creationId xmlns:a16="http://schemas.microsoft.com/office/drawing/2014/main" id="{0F095763-55C9-5D2D-F40A-0CD17324E09C}"/>
+              </a:ext>
+            </a:extLst>
+          </p:cNvPr>
+          <p:cNvSpPr>
+            <a:spLocks noGrp="1"/>
+          </p:cNvSpPr>
+          <p:nvPr>
+            <p:ph idx="1"/>
+          </p:nvPr>
+        </p:nvSpPr>
+        <p:spPr/>
+        <p:txBody>
+          <a:bodyPr/>
+          <a:lstStyle/>
+          <a:p>
+            <a:r>
+              <a:rPr lang="en-US" dirty="0"/>
+              <a:t>Unit testing is done using Junit. Jupiter and Mockito exist to help test in a void.</a:t>
+            </a:r>
+          </a:p>
+          <a:p>
+            <a:r>
+              <a:rPr lang="en-US" dirty="0"/>
+              <a:t>Unit test goes over the service layer to ensure any input results in an expected output</a:t>
+            </a:r>
+          </a:p>
+          <a:p>
+            <a:endParaRPr lang="en-US" dirty="0"/>
+          </a:p>
+          <a:p>
+            <a:r>
+              <a:rPr lang="en-US" dirty="0"/>
+              <a:t>Positive test to ensure the function works, negative tests to ensure graceful error handling.</a:t>
+            </a:r>
+          </a:p>
+          <a:p>
+            <a:endParaRPr lang="en-US" dirty="0"/>
+          </a:p>
+          <a:p>
+            <a:endParaRPr lang="en-US" dirty="0"/>
+          </a:p>
+        </p:txBody>
+      </p:sp>
+      <p:pic>
+        <p:nvPicPr>
+          <p:cNvPr id="5" name="Picture 4">
+            <a:extLst>
+              <a:ext uri="{FF2B5EF4-FFF2-40B4-BE49-F238E27FC236}">
+                <a16:creationId xmlns:a16="http://schemas.microsoft.com/office/drawing/2014/main" id="{D303D894-8A6F-7FDF-7840-69E62BB0B6D7}"/>
+              </a:ext>
+            </a:extLst>
+          </p:cNvPr>
+          <p:cNvPicPr>
+            <a:picLocks noChangeAspect="1"/>
+          </p:cNvPicPr>
+          <p:nvPr/>
+        </p:nvPicPr>
+        <p:blipFill>
+          <a:blip r:embed="rId3"/>
+          <a:stretch>
+            <a:fillRect/>
+          </a:stretch>
+        </p:blipFill>
+        <p:spPr>
+          <a:xfrm>
+            <a:off x="173734" y="4735328"/>
+            <a:ext cx="3535318" cy="1980433"/>
+          </a:xfrm>
+          <a:prstGeom prst="rect">
+            <a:avLst/>
+          </a:prstGeom>
+        </p:spPr>
+      </p:pic>
+      <p:pic>
+        <p:nvPicPr>
+          <p:cNvPr id="7" name="Picture 6">
+            <a:extLst>
+              <a:ext uri="{FF2B5EF4-FFF2-40B4-BE49-F238E27FC236}">
+                <a16:creationId xmlns:a16="http://schemas.microsoft.com/office/drawing/2014/main" id="{6E1429B8-2710-74B3-5469-199F271C843E}"/>
+              </a:ext>
+            </a:extLst>
+          </p:cNvPr>
+          <p:cNvPicPr>
+            <a:picLocks noChangeAspect="1"/>
+          </p:cNvPicPr>
+          <p:nvPr/>
+        </p:nvPicPr>
+        <p:blipFill>
+          <a:blip r:embed="rId4"/>
+          <a:stretch>
+            <a:fillRect/>
+          </a:stretch>
+        </p:blipFill>
+        <p:spPr>
+          <a:xfrm>
+            <a:off x="8576733" y="4723651"/>
+            <a:ext cx="3415361" cy="2031551"/>
+          </a:xfrm>
+          <a:prstGeom prst="rect">
+            <a:avLst/>
+          </a:prstGeom>
+        </p:spPr>
+      </p:pic>
+      <p:pic>
+        <p:nvPicPr>
+          <p:cNvPr id="6" name="Picture 5">
+            <a:extLst>
+              <a:ext uri="{FF2B5EF4-FFF2-40B4-BE49-F238E27FC236}">
+                <a16:creationId xmlns:a16="http://schemas.microsoft.com/office/drawing/2014/main" id="{88F4E8F0-D803-E8DA-B5D5-4BB2BCCCD295}"/>
+              </a:ext>
+            </a:extLst>
+          </p:cNvPr>
+          <p:cNvPicPr>
+            <a:picLocks noChangeAspect="1"/>
+          </p:cNvPicPr>
+          <p:nvPr/>
+        </p:nvPicPr>
+        <p:blipFill>
+          <a:blip r:embed="rId5"/>
+          <a:stretch>
+            <a:fillRect/>
+          </a:stretch>
+        </p:blipFill>
+        <p:spPr>
+          <a:xfrm>
+            <a:off x="2137635" y="3244344"/>
+            <a:ext cx="7916729" cy="1490984"/>
+          </a:xfrm>
+          <a:prstGeom prst="rect">
+            <a:avLst/>
+          </a:prstGeom>
+        </p:spPr>
+      </p:pic>
+    </p:spTree>
+    <p:extLst>
+      <p:ext uri="{BB962C8B-B14F-4D97-AF65-F5344CB8AC3E}">
+        <p14:creationId xmlns:p14="http://schemas.microsoft.com/office/powerpoint/2010/main" val="3640341080"/>
+      </p:ext>
+    </p:extLst>
+  </p:cSld>
+  <p:clrMapOvr>
+    <a:masterClrMapping/>
+  </p:clrMapOvr>
+</p:sld>
+</file>
+
+<file path=ppt/slides/slide8.xml><?xml version="1.0" encoding="utf-8"?>
+<p:sld xmlns:a="http://schemas.openxmlformats.org/drawingml/2006/main" xmlns:r="http://schemas.openxmlformats.org/officeDocument/2006/relationships" xmlns:p="http://schemas.openxmlformats.org/presentationml/2006/main">
+  <p:cSld>
+    <p:spTree>
+      <p:nvGrpSpPr>
+        <p:cNvPr id="1" name=""/>
+        <p:cNvGrpSpPr/>
+        <p:nvPr/>
+      </p:nvGrpSpPr>
+      <p:grpSpPr>
+        <a:xfrm>
+          <a:off x="0" y="0"/>
+          <a:ext cx="0" cy="0"/>
+          <a:chOff x="0" y="0"/>
+          <a:chExt cx="0" cy="0"/>
+        </a:xfrm>
+      </p:grpSpPr>
+      <p:sp>
+        <p:nvSpPr>
+          <p:cNvPr id="2" name="Title 1">
+            <a:extLst>
+              <a:ext uri="{FF2B5EF4-FFF2-40B4-BE49-F238E27FC236}">
                 <a16:creationId xmlns:a16="http://schemas.microsoft.com/office/drawing/2014/main" id="{50DF65A3-DD9B-E59D-5E78-88BFB9BB1D28}"/>
               </a:ext>
             </a:extLst>
@@ -10807,7 +11288,7 @@
 </p:sld>
 </file>
 
-<file path=ppt/slides/slide5.xml><?xml version="1.0" encoding="utf-8"?>
+<file path=ppt/slides/slide9.xml><?xml version="1.0" encoding="utf-8"?>
 <p:sld xmlns:a="http://schemas.openxmlformats.org/drawingml/2006/main" xmlns:r="http://schemas.openxmlformats.org/officeDocument/2006/relationships" xmlns:p="http://schemas.openxmlformats.org/presentationml/2006/main">
   <p:cSld>
     <p:spTree>

</xml_diff>

<commit_message>
BigDecimal conversion and primitive PIN checking: - Replaced doubles with BigDecimal when it came to money to enforce best practices.    - Referenced it inside of the test cases    - Reworked the api layer to make it work - Enforced some more visual queues on the api layer. - Added changes to the slides - Added SQL Error handling and logging
Todo:
- Verify that everything still works and fix whatever does not
- Maybe add other exception types
- Maybe actually change PINs to Strings
</commit_message>
<xml_diff>
--- a/documents/Bank repl.pptx
+++ b/documents/Bank repl.pptx
@@ -10771,10 +10771,10 @@
       </p:sp>
       <p:pic>
         <p:nvPicPr>
-          <p:cNvPr id="7" name="Picture 6">
-            <a:extLst>
-              <a:ext uri="{FF2B5EF4-FFF2-40B4-BE49-F238E27FC236}">
-                <a16:creationId xmlns:a16="http://schemas.microsoft.com/office/drawing/2014/main" id="{FCB3BD4E-5A75-31F6-0466-383B846B5591}"/>
+          <p:cNvPr id="9" name="Picture 8">
+            <a:extLst>
+              <a:ext uri="{FF2B5EF4-FFF2-40B4-BE49-F238E27FC236}">
+                <a16:creationId xmlns:a16="http://schemas.microsoft.com/office/drawing/2014/main" id="{E202F982-8CC5-0CF0-A61F-D88BC3199902}"/>
               </a:ext>
             </a:extLst>
           </p:cNvPr>
@@ -10791,8 +10791,8 @@
         </p:blipFill>
         <p:spPr>
           <a:xfrm>
-            <a:off x="2379168" y="2696667"/>
-            <a:ext cx="7433663" cy="4074286"/>
+            <a:off x="2794248" y="2783158"/>
+            <a:ext cx="6603503" cy="3985730"/>
           </a:xfrm>
           <a:prstGeom prst="rect">
             <a:avLst/>

</xml_diff>

<commit_message>
Contains demo and presentation links on pptx
</commit_message>
<xml_diff>
--- a/documents/Bank repl.pptx
+++ b/documents/Bank repl.pptx
@@ -10291,6 +10291,12 @@
               <a:t>Dennis Keithly</a:t>
             </a:r>
           </a:p>
+          <a:p>
+            <a:r>
+              <a:rPr lang="en-US" dirty="0"/>
+              <a:t>Link to video: https://drive.google.com/file/d/1q-P1G7MH587yaWkRgnMuvp_aJxI46_zO/view?usp=sharing</a:t>
+            </a:r>
+          </a:p>
         </p:txBody>
       </p:sp>
     </p:spTree>
@@ -10655,10 +10661,10 @@
       </p:sp>
       <p:pic>
         <p:nvPicPr>
-          <p:cNvPr id="5" name="Picture 4">
-            <a:extLst>
-              <a:ext uri="{FF2B5EF4-FFF2-40B4-BE49-F238E27FC236}">
-                <a16:creationId xmlns:a16="http://schemas.microsoft.com/office/drawing/2014/main" id="{E5E33D75-653C-BAA2-9CED-717F8666ED59}"/>
+          <p:cNvPr id="11" name="Picture 10">
+            <a:extLst>
+              <a:ext uri="{FF2B5EF4-FFF2-40B4-BE49-F238E27FC236}">
+                <a16:creationId xmlns:a16="http://schemas.microsoft.com/office/drawing/2014/main" id="{9269E969-9018-3DE8-1E6C-C6FB846CC87D}"/>
               </a:ext>
             </a:extLst>
           </p:cNvPr>
@@ -10675,8 +10681,8 @@
         </p:blipFill>
         <p:spPr>
           <a:xfrm>
-            <a:off x="2742664" y="2993000"/>
-            <a:ext cx="6706672" cy="3767634"/>
+            <a:off x="2373307" y="3504418"/>
+            <a:ext cx="7445385" cy="2263336"/>
           </a:xfrm>
           <a:prstGeom prst="rect">
             <a:avLst/>
@@ -10771,10 +10777,10 @@
       </p:sp>
       <p:pic>
         <p:nvPicPr>
-          <p:cNvPr id="9" name="Picture 8">
-            <a:extLst>
-              <a:ext uri="{FF2B5EF4-FFF2-40B4-BE49-F238E27FC236}">
-                <a16:creationId xmlns:a16="http://schemas.microsoft.com/office/drawing/2014/main" id="{E202F982-8CC5-0CF0-A61F-D88BC3199902}"/>
+          <p:cNvPr id="11" name="Picture 10">
+            <a:extLst>
+              <a:ext uri="{FF2B5EF4-FFF2-40B4-BE49-F238E27FC236}">
+                <a16:creationId xmlns:a16="http://schemas.microsoft.com/office/drawing/2014/main" id="{728B2A37-EF05-CE35-FAEE-511114B53EC4}"/>
               </a:ext>
             </a:extLst>
           </p:cNvPr>
@@ -10791,8 +10797,8 @@
         </p:blipFill>
         <p:spPr>
           <a:xfrm>
-            <a:off x="2794248" y="2783158"/>
-            <a:ext cx="6603503" cy="3985730"/>
+            <a:off x="3303337" y="2577903"/>
+            <a:ext cx="5585326" cy="4184218"/>
           </a:xfrm>
           <a:prstGeom prst="rect">
             <a:avLst/>
@@ -10887,10 +10893,10 @@
       </p:sp>
       <p:pic>
         <p:nvPicPr>
-          <p:cNvPr id="5" name="Picture 4">
-            <a:extLst>
-              <a:ext uri="{FF2B5EF4-FFF2-40B4-BE49-F238E27FC236}">
-                <a16:creationId xmlns:a16="http://schemas.microsoft.com/office/drawing/2014/main" id="{7D06044D-1C80-E538-DDDB-2A4F7ACD3F65}"/>
+          <p:cNvPr id="7" name="Picture 6">
+            <a:extLst>
+              <a:ext uri="{FF2B5EF4-FFF2-40B4-BE49-F238E27FC236}">
+                <a16:creationId xmlns:a16="http://schemas.microsoft.com/office/drawing/2014/main" id="{0C3C9729-7712-4005-D95F-3FC3D06EF38A}"/>
               </a:ext>
             </a:extLst>
           </p:cNvPr>
@@ -10907,8 +10913,8 @@
         </p:blipFill>
         <p:spPr>
           <a:xfrm>
-            <a:off x="2186540" y="2645865"/>
-            <a:ext cx="7818919" cy="4125320"/>
+            <a:off x="2815431" y="2671266"/>
+            <a:ext cx="6561137" cy="4099006"/>
           </a:xfrm>
           <a:prstGeom prst="rect">
             <a:avLst/>
@@ -11358,6 +11364,16 @@
               <a:rPr lang="en-US" dirty="0"/>
               <a:t>To show the functions and how the application works, let’s move into the demo.</a:t>
             </a:r>
+          </a:p>
+          <a:p>
+            <a:endParaRPr lang="en-US" dirty="0"/>
+          </a:p>
+          <a:p>
+            <a:r>
+              <a:rPr lang="en-US"/>
+              <a:t>Link to video: https://drive.google.com/file/d/1cFTHKB8K-odduKhYF5Ry_bQ85IVO-2dP/view?usp=sharing</a:t>
+            </a:r>
+            <a:endParaRPr lang="en-US" dirty="0"/>
           </a:p>
         </p:txBody>
       </p:sp>

</xml_diff>